<commit_message>
updates to course oct 9
</commit_message>
<xml_diff>
--- a/docs/lecture_slides/Week 7/2026/Week7_Lecture17_Slides_10_9_2026.pptx
+++ b/docs/lecture_slides/Week 7/2026/Week7_Lecture17_Slides_10_9_2026.pptx
@@ -10,13 +10,16 @@
     <p:sldId id="397" r:id="rId4"/>
     <p:sldId id="407" r:id="rId5"/>
     <p:sldId id="398" r:id="rId6"/>
-    <p:sldId id="399" r:id="rId7"/>
-    <p:sldId id="400" r:id="rId8"/>
-    <p:sldId id="401" r:id="rId9"/>
-    <p:sldId id="402" r:id="rId10"/>
-    <p:sldId id="405" r:id="rId11"/>
-    <p:sldId id="406" r:id="rId12"/>
-    <p:sldId id="389" r:id="rId13"/>
+    <p:sldId id="409" r:id="rId7"/>
+    <p:sldId id="399" r:id="rId8"/>
+    <p:sldId id="400" r:id="rId9"/>
+    <p:sldId id="401" r:id="rId10"/>
+    <p:sldId id="408" r:id="rId11"/>
+    <p:sldId id="410" r:id="rId12"/>
+    <p:sldId id="402" r:id="rId13"/>
+    <p:sldId id="405" r:id="rId14"/>
+    <p:sldId id="406" r:id="rId15"/>
+    <p:sldId id="389" r:id="rId16"/>
   </p:sldIdLst>
   <p:sldSz cx="12192000" cy="6858000"/>
   <p:notesSz cx="6858000" cy="9144000"/>
@@ -270,7 +273,7 @@
           <a:p>
             <a:fld id="{06882561-BD16-4A95-ACA1-5204E478F2FE}" type="datetimeFigureOut">
               <a:rPr lang="en-US" smtClean="0"/>
-              <a:t>10/7/2026</a:t>
+              <a:t>10/9/2026</a:t>
             </a:fld>
             <a:endParaRPr lang="en-US"/>
           </a:p>
@@ -468,7 +471,7 @@
           <a:p>
             <a:fld id="{06882561-BD16-4A95-ACA1-5204E478F2FE}" type="datetimeFigureOut">
               <a:rPr lang="en-US" smtClean="0"/>
-              <a:t>10/7/2026</a:t>
+              <a:t>10/9/2026</a:t>
             </a:fld>
             <a:endParaRPr lang="en-US"/>
           </a:p>
@@ -676,7 +679,7 @@
           <a:p>
             <a:fld id="{06882561-BD16-4A95-ACA1-5204E478F2FE}" type="datetimeFigureOut">
               <a:rPr lang="en-US" smtClean="0"/>
-              <a:t>10/7/2026</a:t>
+              <a:t>10/9/2026</a:t>
             </a:fld>
             <a:endParaRPr lang="en-US"/>
           </a:p>
@@ -874,7 +877,7 @@
           <a:p>
             <a:fld id="{06882561-BD16-4A95-ACA1-5204E478F2FE}" type="datetimeFigureOut">
               <a:rPr lang="en-US" smtClean="0"/>
-              <a:t>10/7/2026</a:t>
+              <a:t>10/9/2026</a:t>
             </a:fld>
             <a:endParaRPr lang="en-US"/>
           </a:p>
@@ -1149,7 +1152,7 @@
           <a:p>
             <a:fld id="{06882561-BD16-4A95-ACA1-5204E478F2FE}" type="datetimeFigureOut">
               <a:rPr lang="en-US" smtClean="0"/>
-              <a:t>10/7/2026</a:t>
+              <a:t>10/9/2026</a:t>
             </a:fld>
             <a:endParaRPr lang="en-US"/>
           </a:p>
@@ -1414,7 +1417,7 @@
           <a:p>
             <a:fld id="{06882561-BD16-4A95-ACA1-5204E478F2FE}" type="datetimeFigureOut">
               <a:rPr lang="en-US" smtClean="0"/>
-              <a:t>10/7/2026</a:t>
+              <a:t>10/9/2026</a:t>
             </a:fld>
             <a:endParaRPr lang="en-US"/>
           </a:p>
@@ -1826,7 +1829,7 @@
           <a:p>
             <a:fld id="{06882561-BD16-4A95-ACA1-5204E478F2FE}" type="datetimeFigureOut">
               <a:rPr lang="en-US" smtClean="0"/>
-              <a:t>10/7/2026</a:t>
+              <a:t>10/9/2026</a:t>
             </a:fld>
             <a:endParaRPr lang="en-US"/>
           </a:p>
@@ -1967,7 +1970,7 @@
           <a:p>
             <a:fld id="{06882561-BD16-4A95-ACA1-5204E478F2FE}" type="datetimeFigureOut">
               <a:rPr lang="en-US" smtClean="0"/>
-              <a:t>10/7/2026</a:t>
+              <a:t>10/9/2026</a:t>
             </a:fld>
             <a:endParaRPr lang="en-US"/>
           </a:p>
@@ -2080,7 +2083,7 @@
           <a:p>
             <a:fld id="{06882561-BD16-4A95-ACA1-5204E478F2FE}" type="datetimeFigureOut">
               <a:rPr lang="en-US" smtClean="0"/>
-              <a:t>10/7/2026</a:t>
+              <a:t>10/9/2026</a:t>
             </a:fld>
             <a:endParaRPr lang="en-US"/>
           </a:p>
@@ -2391,7 +2394,7 @@
           <a:p>
             <a:fld id="{06882561-BD16-4A95-ACA1-5204E478F2FE}" type="datetimeFigureOut">
               <a:rPr lang="en-US" smtClean="0"/>
-              <a:t>10/7/2026</a:t>
+              <a:t>10/9/2026</a:t>
             </a:fld>
             <a:endParaRPr lang="en-US"/>
           </a:p>
@@ -2679,7 +2682,7 @@
           <a:p>
             <a:fld id="{06882561-BD16-4A95-ACA1-5204E478F2FE}" type="datetimeFigureOut">
               <a:rPr lang="en-US" smtClean="0"/>
-              <a:t>10/7/2026</a:t>
+              <a:t>10/9/2026</a:t>
             </a:fld>
             <a:endParaRPr lang="en-US"/>
           </a:p>
@@ -2920,7 +2923,7 @@
           <a:p>
             <a:fld id="{06882561-BD16-4A95-ACA1-5204E478F2FE}" type="datetimeFigureOut">
               <a:rPr lang="en-US" smtClean="0"/>
-              <a:t>10/7/2026</a:t>
+              <a:t>10/9/2026</a:t>
             </a:fld>
             <a:endParaRPr lang="en-US"/>
           </a:p>
@@ -3432,7 +3435,7 @@
           <p:cNvPr id="2" name="Title 1">
             <a:extLst>
               <a:ext uri="{FF2B5EF4-FFF2-40B4-BE49-F238E27FC236}">
-                <a16:creationId xmlns:a16="http://schemas.microsoft.com/office/drawing/2014/main" id="{D617AB41-6AD1-9EF2-7F95-46A904399681}"/>
+                <a16:creationId xmlns:a16="http://schemas.microsoft.com/office/drawing/2014/main" id="{C08D30B1-1864-30EF-7EAB-9BEE656C0012}"/>
               </a:ext>
             </a:extLst>
           </p:cNvPr>
@@ -3456,7 +3459,7 @@
                   <a:srgbClr val="1F3864"/>
                 </a:solidFill>
               </a:rPr>
-              <a:t>Cumulative probability</a:t>
+              <a:t>Example: texts during class</a:t>
             </a:r>
           </a:p>
         </p:txBody>
@@ -3466,7 +3469,7 @@
           <p:cNvPr id="4" name="Slide Number Placeholder 3">
             <a:extLst>
               <a:ext uri="{FF2B5EF4-FFF2-40B4-BE49-F238E27FC236}">
-                <a16:creationId xmlns:a16="http://schemas.microsoft.com/office/drawing/2014/main" id="{97D44AE5-98B5-B840-6B8A-D345C7C2E2F0}"/>
+                <a16:creationId xmlns:a16="http://schemas.microsoft.com/office/drawing/2014/main" id="{3F875068-D051-44AE-498E-1BEBEDE3A7C8}"/>
               </a:ext>
             </a:extLst>
           </p:cNvPr>
@@ -3485,6 +3488,1813 @@
             <a:fld id="{A80A81DD-F10A-4B1C-963A-0ABBB4865886}" type="slidenum">
               <a:rPr lang="en-US" sz="1600" smtClean="0"/>
               <a:t>10</a:t>
+            </a:fld>
+            <a:endParaRPr lang="en-US" sz="1600"/>
+          </a:p>
+        </p:txBody>
+      </p:sp>
+      <p:sp>
+        <p:nvSpPr>
+          <p:cNvPr id="3" name="Title rule">
+            <a:extLst>
+              <a:ext uri="{FF2B5EF4-FFF2-40B4-BE49-F238E27FC236}">
+                <a16:creationId xmlns:a16="http://schemas.microsoft.com/office/drawing/2014/main" id="{30656AA8-9645-F028-C769-A313710853CC}"/>
+              </a:ext>
+            </a:extLst>
+          </p:cNvPr>
+          <p:cNvSpPr/>
+          <p:nvPr/>
+        </p:nvSpPr>
+        <p:spPr>
+          <a:xfrm>
+            <a:off x="838200" y="1600200"/>
+            <a:ext cx="10515600" cy="38100"/>
+          </a:xfrm>
+          <a:prstGeom prst="rect">
+            <a:avLst/>
+          </a:prstGeom>
+          <a:solidFill>
+            <a:srgbClr val="4472C4"/>
+          </a:solidFill>
+          <a:ln w="12700" cap="flat" cmpd="sng" algn="ctr">
+            <a:noFill/>
+            <a:prstDash val="solid"/>
+            <a:miter lim="800000"/>
+          </a:ln>
+          <a:effectLst/>
+          <a:extLst>
+            <a:ext uri="{91240B29-F687-4F45-9708-019B960494DF}">
+              <a14:hiddenLine xmlns:a14="http://schemas.microsoft.com/office/drawing/2010/main" w="12700" cap="flat" cmpd="sng" algn="ctr">
+                <a:solidFill>
+                  <a:schemeClr val="accent1">
+                    <a:shade val="15000"/>
+                  </a:schemeClr>
+                </a:solidFill>
+                <a:prstDash val="solid"/>
+                <a:miter lim="800000"/>
+              </a14:hiddenLine>
+            </a:ext>
+          </a:extLst>
+        </p:spPr>
+        <p:style>
+          <a:lnRef idx="2">
+            <a:schemeClr val="accent1">
+              <a:shade val="15000"/>
+            </a:schemeClr>
+          </a:lnRef>
+          <a:fillRef idx="1">
+            <a:schemeClr val="accent1"/>
+          </a:fillRef>
+          <a:effectRef idx="0">
+            <a:schemeClr val="accent1"/>
+          </a:effectRef>
+          <a:fontRef idx="minor">
+            <a:schemeClr val="lt1"/>
+          </a:fontRef>
+        </p:style>
+        <p:txBody>
+          <a:bodyPr rtlCol="0" anchor="ctr"/>
+          <a:lstStyle/>
+          <a:p>
+            <a:pPr algn="ctr"/>
+            <a:endParaRPr lang="en-US"/>
+          </a:p>
+        </p:txBody>
+      </p:sp>
+      <p:sp>
+        <p:nvSpPr>
+          <p:cNvPr id="8" name="Context">
+            <a:extLst>
+              <a:ext uri="{FF2B5EF4-FFF2-40B4-BE49-F238E27FC236}">
+                <a16:creationId xmlns:a16="http://schemas.microsoft.com/office/drawing/2014/main" id="{71E3EA8C-31B4-DAD4-BC4A-65D72E59AD46}"/>
+              </a:ext>
+            </a:extLst>
+          </p:cNvPr>
+          <p:cNvSpPr txBox="1"/>
+          <p:nvPr/>
+        </p:nvSpPr>
+        <p:spPr>
+          <a:xfrm>
+            <a:off x="762000" y="1879600"/>
+            <a:ext cx="10668000" cy="381000"/>
+          </a:xfrm>
+          <a:prstGeom prst="rect">
+            <a:avLst/>
+          </a:prstGeom>
+          <a:noFill/>
+        </p:spPr>
+        <p:txBody>
+          <a:bodyPr vert="horz" wrap="square" rtlCol="0">
+            <a:spAutoFit/>
+          </a:bodyPr>
+          <a:lstStyle/>
+          <a:p>
+            <a:pPr>
+              <a:spcAft>
+                <a:spcPts val="200"/>
+              </a:spcAft>
+            </a:pPr>
+            <a:r>
+              <a:rPr lang="en-US">
+                <a:solidFill>
+                  <a:srgbClr val="000000"/>
+                </a:solidFill>
+                <a:latin typeface="Calibri" panose="020F0502020204030204" pitchFamily="34" charset="0"/>
+              </a:rPr>
+              <a:t>You get an average of 2 text messages every 10 minutes of class:  X ~ Poisson(λ = 2).</a:t>
+            </a:r>
+          </a:p>
+        </p:txBody>
+      </p:sp>
+      <p:sp>
+        <p:nvSpPr>
+          <p:cNvPr id="10" name="Question">
+            <a:extLst>
+              <a:ext uri="{FF2B5EF4-FFF2-40B4-BE49-F238E27FC236}">
+                <a16:creationId xmlns:a16="http://schemas.microsoft.com/office/drawing/2014/main" id="{B31E395F-B84E-D1E9-D22A-222467FC4105}"/>
+              </a:ext>
+            </a:extLst>
+          </p:cNvPr>
+          <p:cNvSpPr txBox="1"/>
+          <p:nvPr/>
+        </p:nvSpPr>
+        <p:spPr>
+          <a:xfrm>
+            <a:off x="762000" y="2286000"/>
+            <a:ext cx="10668000" cy="369332"/>
+          </a:xfrm>
+          <a:prstGeom prst="rect">
+            <a:avLst/>
+          </a:prstGeom>
+          <a:noFill/>
+        </p:spPr>
+        <p:txBody>
+          <a:bodyPr vert="horz" wrap="square" rtlCol="0">
+            <a:spAutoFit/>
+          </a:bodyPr>
+          <a:lstStyle/>
+          <a:p>
+            <a:pPr>
+              <a:spcAft>
+                <a:spcPts val="200"/>
+              </a:spcAft>
+            </a:pPr>
+            <a:r>
+              <a:rPr lang="en-US" b="1">
+                <a:solidFill>
+                  <a:srgbClr val="C00000"/>
+                </a:solidFill>
+                <a:latin typeface="Calibri" panose="020F0502020204030204" pitchFamily="34" charset="0"/>
+              </a:rPr>
+              <a:t>Use the bars:   (a)  P(X ≤ 1)?     (b)  P(X ≥ 3)?     (c)  P(2 ≤ X ≤ 4)?</a:t>
+            </a:r>
+          </a:p>
+        </p:txBody>
+      </p:sp>
+      <p:sp>
+        <p:nvSpPr>
+          <p:cNvPr id="11" name="Result">
+            <a:extLst>
+              <a:ext uri="{FF2B5EF4-FFF2-40B4-BE49-F238E27FC236}">
+                <a16:creationId xmlns:a16="http://schemas.microsoft.com/office/drawing/2014/main" id="{5A70F68E-0D93-07B8-82B2-4D8F2F681D0D}"/>
+              </a:ext>
+            </a:extLst>
+          </p:cNvPr>
+          <p:cNvSpPr/>
+          <p:nvPr/>
+        </p:nvSpPr>
+        <p:spPr>
+          <a:xfrm>
+            <a:off x="762000" y="5486400"/>
+            <a:ext cx="10668000" cy="787400"/>
+          </a:xfrm>
+          <a:prstGeom prst="roundRect">
+            <a:avLst>
+              <a:gd name="adj" fmla="val 4000"/>
+            </a:avLst>
+          </a:prstGeom>
+          <a:solidFill>
+            <a:srgbClr val="F2F6FC"/>
+          </a:solidFill>
+          <a:ln w="15875">
+            <a:solidFill>
+              <a:srgbClr val="4472C4"/>
+            </a:solidFill>
+          </a:ln>
+        </p:spPr>
+        <p:style>
+          <a:lnRef idx="2">
+            <a:schemeClr val="accent1">
+              <a:shade val="15000"/>
+            </a:schemeClr>
+          </a:lnRef>
+          <a:fillRef idx="1">
+            <a:schemeClr val="accent1"/>
+          </a:fillRef>
+          <a:effectRef idx="0">
+            <a:schemeClr val="accent1"/>
+          </a:effectRef>
+          <a:fontRef idx="minor">
+            <a:schemeClr val="lt1"/>
+          </a:fontRef>
+        </p:style>
+        <p:txBody>
+          <a:bodyPr wrap="square" lIns="152400" tIns="76200" rIns="152400" bIns="76200" rtlCol="0" anchor="ctr">
+            <a:spAutoFit/>
+          </a:bodyPr>
+          <a:lstStyle/>
+          <a:p>
+            <a:r>
+              <a:rPr lang="pt-BR" sz="2000" b="1">
+                <a:solidFill>
+                  <a:srgbClr val="C00000"/>
+                </a:solidFill>
+                <a:latin typeface="Calibri" panose="020F0502020204030204" pitchFamily="34" charset="0"/>
+              </a:rPr>
+              <a:t>(a)  0.135 + 0.271 = 0.406          (b)  1 − (0.135 + 0.271 + 0.271) = 0.323</a:t>
+            </a:r>
+          </a:p>
+          <a:p>
+            <a:r>
+              <a:rPr lang="pt-BR" sz="2000" b="1">
+                <a:solidFill>
+                  <a:srgbClr val="C00000"/>
+                </a:solidFill>
+                <a:latin typeface="Calibri" panose="020F0502020204030204" pitchFamily="34" charset="0"/>
+              </a:rPr>
+              <a:t>(c)  0.271 + 0.180 + 0.090 = 0.541</a:t>
+            </a:r>
+            <a:endParaRPr lang="en-US" sz="2000" b="1">
+              <a:solidFill>
+                <a:srgbClr val="C00000"/>
+              </a:solidFill>
+              <a:latin typeface="Calibri" panose="020F0502020204030204" pitchFamily="34" charset="0"/>
+            </a:endParaRPr>
+          </a:p>
+        </p:txBody>
+      </p:sp>
+      <p:pic>
+        <p:nvPicPr>
+          <p:cNvPr id="7" name="l17_pois_texts.png">
+            <a:extLst>
+              <a:ext uri="{FF2B5EF4-FFF2-40B4-BE49-F238E27FC236}">
+                <a16:creationId xmlns:a16="http://schemas.microsoft.com/office/drawing/2014/main" id="{0C4FC89A-1490-8D9D-51E9-77BF86BB9270}"/>
+              </a:ext>
+            </a:extLst>
+          </p:cNvPr>
+          <p:cNvPicPr>
+            <a:picLocks/>
+          </p:cNvPicPr>
+          <p:nvPr/>
+        </p:nvPicPr>
+        <p:blipFill>
+          <a:blip r:embed="rId2">
+            <a:extLst>
+              <a:ext uri="{28A0092B-C50C-407E-A947-70E740481C1C}">
+                <a14:useLocalDpi xmlns:a14="http://schemas.microsoft.com/office/drawing/2010/main" val="0"/>
+              </a:ext>
+            </a:extLst>
+          </a:blip>
+          <a:stretch>
+            <a:fillRect/>
+          </a:stretch>
+        </p:blipFill>
+        <p:spPr>
+          <a:xfrm>
+            <a:off x="2032000" y="2705100"/>
+            <a:ext cx="8128000" cy="2730500"/>
+          </a:xfrm>
+          <a:prstGeom prst="rect">
+            <a:avLst/>
+          </a:prstGeom>
+        </p:spPr>
+      </p:pic>
+    </p:spTree>
+    <p:extLst>
+      <p:ext uri="{BB962C8B-B14F-4D97-AF65-F5344CB8AC3E}">
+        <p14:creationId xmlns:p14="http://schemas.microsoft.com/office/powerpoint/2010/main" val="3609575565"/>
+      </p:ext>
+    </p:extLst>
+  </p:cSld>
+  <p:clrMapOvr>
+    <a:masterClrMapping/>
+  </p:clrMapOvr>
+  <p:timing>
+    <p:tnLst>
+      <p:par>
+        <p:cTn id="1" dur="indefinite" restart="never" nodeType="tmRoot">
+          <p:childTnLst>
+            <p:seq concurrent="1" nextAc="seek">
+              <p:cTn id="2" dur="indefinite" nodeType="mainSeq">
+                <p:childTnLst>
+                  <p:par>
+                    <p:cTn id="3" fill="hold">
+                      <p:stCondLst>
+                        <p:cond delay="indefinite"/>
+                      </p:stCondLst>
+                      <p:childTnLst>
+                        <p:par>
+                          <p:cTn id="4" fill="hold">
+                            <p:stCondLst>
+                              <p:cond delay="0"/>
+                            </p:stCondLst>
+                            <p:childTnLst>
+                              <p:par>
+                                <p:cTn id="5" presetID="1" presetClass="entr" presetSubtype="0" fill="hold" grpId="0" nodeType="clickEffect">
+                                  <p:stCondLst>
+                                    <p:cond delay="0"/>
+                                  </p:stCondLst>
+                                  <p:childTnLst>
+                                    <p:set>
+                                      <p:cBhvr>
+                                        <p:cTn id="6" dur="1" fill="hold">
+                                          <p:stCondLst>
+                                            <p:cond delay="0"/>
+                                          </p:stCondLst>
+                                        </p:cTn>
+                                        <p:tgtEl>
+                                          <p:spTgt spid="11"/>
+                                        </p:tgtEl>
+                                        <p:attrNameLst>
+                                          <p:attrName>style.visibility</p:attrName>
+                                        </p:attrNameLst>
+                                      </p:cBhvr>
+                                      <p:to>
+                                        <p:strVal val="visible"/>
+                                      </p:to>
+                                    </p:set>
+                                  </p:childTnLst>
+                                </p:cTn>
+                              </p:par>
+                            </p:childTnLst>
+                          </p:cTn>
+                        </p:par>
+                      </p:childTnLst>
+                    </p:cTn>
+                  </p:par>
+                </p:childTnLst>
+              </p:cTn>
+              <p:prevCondLst>
+                <p:cond evt="onPrev" delay="0">
+                  <p:tgtEl>
+                    <p:sldTgt/>
+                  </p:tgtEl>
+                </p:cond>
+              </p:prevCondLst>
+              <p:nextCondLst>
+                <p:cond evt="onNext" delay="0">
+                  <p:tgtEl>
+                    <p:sldTgt/>
+                  </p:tgtEl>
+                </p:cond>
+              </p:nextCondLst>
+            </p:seq>
+          </p:childTnLst>
+        </p:cTn>
+      </p:par>
+    </p:tnLst>
+    <p:bldLst>
+      <p:bldP spid="11" grpId="0" animBg="1"/>
+    </p:bldLst>
+  </p:timing>
+</p:sld>
+</file>
+
+<file path=ppt/slides/slide11.xml><?xml version="1.0" encoding="utf-8"?>
+<p:sld xmlns:a="http://schemas.openxmlformats.org/drawingml/2006/main" xmlns:r="http://schemas.openxmlformats.org/officeDocument/2006/relationships" xmlns:p="http://schemas.openxmlformats.org/presentationml/2006/main">
+  <p:cSld>
+    <p:spTree>
+      <p:nvGrpSpPr>
+        <p:cNvPr id="1" name=""/>
+        <p:cNvGrpSpPr/>
+        <p:nvPr/>
+      </p:nvGrpSpPr>
+      <p:grpSpPr>
+        <a:xfrm>
+          <a:off x="0" y="0"/>
+          <a:ext cx="0" cy="0"/>
+          <a:chOff x="0" y="0"/>
+          <a:chExt cx="0" cy="0"/>
+        </a:xfrm>
+      </p:grpSpPr>
+      <p:sp>
+        <p:nvSpPr>
+          <p:cNvPr id="2" name="Title 1">
+            <a:extLst>
+              <a:ext uri="{FF2B5EF4-FFF2-40B4-BE49-F238E27FC236}">
+                <a16:creationId xmlns:a16="http://schemas.microsoft.com/office/drawing/2014/main" id="{D617AB41-6AD1-9EF2-7F95-46A904399681}"/>
+              </a:ext>
+            </a:extLst>
+          </p:cNvPr>
+          <p:cNvSpPr>
+            <a:spLocks noGrp="1"/>
+          </p:cNvSpPr>
+          <p:nvPr>
+            <p:ph type="title"/>
+          </p:nvPr>
+        </p:nvSpPr>
+        <p:spPr/>
+        <p:txBody>
+          <a:bodyPr>
+            <a:noAutofit/>
+          </a:bodyPr>
+          <a:lstStyle/>
+          <a:p>
+            <a:r>
+              <a:rPr lang="en-US">
+                <a:solidFill>
+                  <a:srgbClr val="1F3864"/>
+                </a:solidFill>
+              </a:rPr>
+              <a:t>Probability mass vs. probability density</a:t>
+            </a:r>
+          </a:p>
+        </p:txBody>
+      </p:sp>
+      <p:sp>
+        <p:nvSpPr>
+          <p:cNvPr id="4" name="Slide Number Placeholder 3">
+            <a:extLst>
+              <a:ext uri="{FF2B5EF4-FFF2-40B4-BE49-F238E27FC236}">
+                <a16:creationId xmlns:a16="http://schemas.microsoft.com/office/drawing/2014/main" id="{97D44AE5-98B5-B840-6B8A-D345C7C2E2F0}"/>
+              </a:ext>
+            </a:extLst>
+          </p:cNvPr>
+          <p:cNvSpPr>
+            <a:spLocks noGrp="1"/>
+          </p:cNvSpPr>
+          <p:nvPr>
+            <p:ph type="sldNum" sz="quarter" idx="12"/>
+          </p:nvPr>
+        </p:nvSpPr>
+        <p:spPr/>
+        <p:txBody>
+          <a:bodyPr/>
+          <a:lstStyle/>
+          <a:p>
+            <a:fld id="{A80A81DD-F10A-4B1C-963A-0ABBB4865886}" type="slidenum">
+              <a:rPr lang="en-US" sz="1600" smtClean="0"/>
+              <a:t>11</a:t>
+            </a:fld>
+            <a:endParaRPr lang="en-US" sz="1600"/>
+          </a:p>
+        </p:txBody>
+      </p:sp>
+      <p:sp>
+        <p:nvSpPr>
+          <p:cNvPr id="5" name="TextBox 4">
+            <a:extLst>
+              <a:ext uri="{FF2B5EF4-FFF2-40B4-BE49-F238E27FC236}">
+                <a16:creationId xmlns:a16="http://schemas.microsoft.com/office/drawing/2014/main" id="{A34AAE17-27CE-D7A3-C663-11BB48ACBF5B}"/>
+              </a:ext>
+            </a:extLst>
+          </p:cNvPr>
+          <p:cNvSpPr txBox="1"/>
+          <p:nvPr/>
+        </p:nvSpPr>
+        <p:spPr>
+          <a:xfrm>
+            <a:off x="762000" y="4699000"/>
+            <a:ext cx="10668000" cy="345440"/>
+          </a:xfrm>
+          <a:prstGeom prst="rect">
+            <a:avLst/>
+          </a:prstGeom>
+          <a:noFill/>
+        </p:spPr>
+        <p:txBody>
+          <a:bodyPr vert="horz" wrap="square" rtlCol="0">
+            <a:spAutoFit/>
+          </a:bodyPr>
+          <a:lstStyle/>
+          <a:p>
+            <a:pPr marL="304800" indent="-304800"/>
+            <a:r>
+              <a:rPr lang="en-US" sz="1600">
+                <a:solidFill>
+                  <a:srgbClr val="000000"/>
+                </a:solidFill>
+              </a:rPr>
+              <a:t>probability mass  (discrete)</a:t>
+            </a:r>
+          </a:p>
+        </p:txBody>
+      </p:sp>
+      <p:sp>
+        <p:nvSpPr>
+          <p:cNvPr id="6" name="TextBox 5">
+            <a:extLst>
+              <a:ext uri="{FF2B5EF4-FFF2-40B4-BE49-F238E27FC236}">
+                <a16:creationId xmlns:a16="http://schemas.microsoft.com/office/drawing/2014/main" id="{E410A0F8-5E1E-9A1D-B64C-50827EE6C9B2}"/>
+              </a:ext>
+            </a:extLst>
+          </p:cNvPr>
+          <p:cNvSpPr txBox="1"/>
+          <p:nvPr/>
+        </p:nvSpPr>
+        <p:spPr>
+          <a:xfrm>
+            <a:off x="1117600" y="5041900"/>
+            <a:ext cx="10312400" cy="338554"/>
+          </a:xfrm>
+          <a:prstGeom prst="rect">
+            <a:avLst/>
+          </a:prstGeom>
+          <a:noFill/>
+        </p:spPr>
+        <p:txBody>
+          <a:bodyPr vert="horz" wrap="square" rtlCol="0">
+            <a:spAutoFit/>
+          </a:bodyPr>
+          <a:lstStyle/>
+          <a:p>
+            <a:r>
+              <a:rPr lang="en-US" sz="1600" b="1">
+                <a:solidFill>
+                  <a:srgbClr val="C00000"/>
+                </a:solidFill>
+              </a:rPr>
+              <a:t>each value carries its own packet of probability, P(X = k), and the packets add to 1</a:t>
+            </a:r>
+          </a:p>
+        </p:txBody>
+      </p:sp>
+      <p:sp>
+        <p:nvSpPr>
+          <p:cNvPr id="7" name="TextBox 6">
+            <a:extLst>
+              <a:ext uri="{FF2B5EF4-FFF2-40B4-BE49-F238E27FC236}">
+                <a16:creationId xmlns:a16="http://schemas.microsoft.com/office/drawing/2014/main" id="{47D3CD95-D52E-5227-B663-7C0A72677B6E}"/>
+              </a:ext>
+            </a:extLst>
+          </p:cNvPr>
+          <p:cNvSpPr txBox="1"/>
+          <p:nvPr/>
+        </p:nvSpPr>
+        <p:spPr>
+          <a:xfrm>
+            <a:off x="762000" y="5486400"/>
+            <a:ext cx="10668000" cy="345440"/>
+          </a:xfrm>
+          <a:prstGeom prst="rect">
+            <a:avLst/>
+          </a:prstGeom>
+          <a:noFill/>
+        </p:spPr>
+        <p:txBody>
+          <a:bodyPr vert="horz" wrap="square" rtlCol="0">
+            <a:spAutoFit/>
+          </a:bodyPr>
+          <a:lstStyle/>
+          <a:p>
+            <a:pPr marL="304800" indent="-304800"/>
+            <a:r>
+              <a:rPr lang="en-US" sz="1600">
+                <a:solidFill>
+                  <a:srgbClr val="000000"/>
+                </a:solidFill>
+              </a:rPr>
+              <a:t>probability density  (continuous)</a:t>
+            </a:r>
+          </a:p>
+        </p:txBody>
+      </p:sp>
+      <p:sp>
+        <p:nvSpPr>
+          <p:cNvPr id="8" name="TextBox 7">
+            <a:extLst>
+              <a:ext uri="{FF2B5EF4-FFF2-40B4-BE49-F238E27FC236}">
+                <a16:creationId xmlns:a16="http://schemas.microsoft.com/office/drawing/2014/main" id="{1CE3E601-601D-C6B1-8265-C079CB8C9269}"/>
+              </a:ext>
+            </a:extLst>
+          </p:cNvPr>
+          <p:cNvSpPr txBox="1"/>
+          <p:nvPr/>
+        </p:nvSpPr>
+        <p:spPr>
+          <a:xfrm>
+            <a:off x="1117600" y="5829300"/>
+            <a:ext cx="10312400" cy="338554"/>
+          </a:xfrm>
+          <a:prstGeom prst="rect">
+            <a:avLst/>
+          </a:prstGeom>
+          <a:noFill/>
+        </p:spPr>
+        <p:txBody>
+          <a:bodyPr vert="horz" wrap="square" rtlCol="0">
+            <a:spAutoFit/>
+          </a:bodyPr>
+          <a:lstStyle/>
+          <a:p>
+            <a:r>
+              <a:rPr lang="en-US" sz="1600" b="1">
+                <a:solidFill>
+                  <a:srgbClr val="C00000"/>
+                </a:solidFill>
+              </a:rPr>
+              <a:t>how concentrated probability is around a point; probability is the area under the curve</a:t>
+            </a:r>
+          </a:p>
+        </p:txBody>
+      </p:sp>
+      <p:sp>
+        <p:nvSpPr>
+          <p:cNvPr id="3" name="Title rule">
+            <a:extLst>
+              <a:ext uri="{FF2B5EF4-FFF2-40B4-BE49-F238E27FC236}">
+                <a16:creationId xmlns:a16="http://schemas.microsoft.com/office/drawing/2014/main" id="{B469CAAB-2B69-6863-7C28-0C5959E5734B}"/>
+              </a:ext>
+            </a:extLst>
+          </p:cNvPr>
+          <p:cNvSpPr/>
+          <p:nvPr/>
+        </p:nvSpPr>
+        <p:spPr>
+          <a:xfrm>
+            <a:off x="838200" y="1600200"/>
+            <a:ext cx="10515600" cy="38100"/>
+          </a:xfrm>
+          <a:prstGeom prst="rect">
+            <a:avLst/>
+          </a:prstGeom>
+          <a:solidFill>
+            <a:srgbClr val="4472C4"/>
+          </a:solidFill>
+          <a:ln w="12700" cap="flat" cmpd="sng" algn="ctr">
+            <a:noFill/>
+            <a:prstDash val="solid"/>
+            <a:miter lim="800000"/>
+          </a:ln>
+          <a:effectLst/>
+          <a:extLst>
+            <a:ext uri="{91240B29-F687-4F45-9708-019B960494DF}">
+              <a14:hiddenLine xmlns:a14="http://schemas.microsoft.com/office/drawing/2010/main" w="12700" cap="flat" cmpd="sng" algn="ctr">
+                <a:solidFill>
+                  <a:schemeClr val="accent1">
+                    <a:shade val="15000"/>
+                  </a:schemeClr>
+                </a:solidFill>
+                <a:prstDash val="solid"/>
+                <a:miter lim="800000"/>
+              </a14:hiddenLine>
+            </a:ext>
+          </a:extLst>
+        </p:spPr>
+        <p:style>
+          <a:lnRef idx="2">
+            <a:schemeClr val="accent1">
+              <a:shade val="15000"/>
+            </a:schemeClr>
+          </a:lnRef>
+          <a:fillRef idx="1">
+            <a:schemeClr val="accent1"/>
+          </a:fillRef>
+          <a:effectRef idx="0">
+            <a:schemeClr val="accent1"/>
+          </a:effectRef>
+          <a:fontRef idx="minor">
+            <a:schemeClr val="lt1"/>
+          </a:fontRef>
+        </p:style>
+        <p:txBody>
+          <a:bodyPr rtlCol="0" anchor="ctr"/>
+          <a:lstStyle/>
+          <a:p>
+            <a:pPr algn="ctr"/>
+            <a:endParaRPr lang="en-US"/>
+          </a:p>
+        </p:txBody>
+      </p:sp>
+      <p:pic>
+        <p:nvPicPr>
+          <p:cNvPr id="12" name="l17_mass_density.png">
+            <a:extLst>
+              <a:ext uri="{FF2B5EF4-FFF2-40B4-BE49-F238E27FC236}">
+                <a16:creationId xmlns:a16="http://schemas.microsoft.com/office/drawing/2014/main" id="{348A651A-D39F-C7DB-58B6-477E74DDE198}"/>
+              </a:ext>
+            </a:extLst>
+          </p:cNvPr>
+          <p:cNvPicPr>
+            <a:picLocks/>
+          </p:cNvPicPr>
+          <p:nvPr/>
+        </p:nvPicPr>
+        <p:blipFill>
+          <a:blip r:embed="rId2">
+            <a:extLst>
+              <a:ext uri="{28A0092B-C50C-407E-A947-70E740481C1C}">
+                <a14:useLocalDpi xmlns:a14="http://schemas.microsoft.com/office/drawing/2010/main" val="0"/>
+              </a:ext>
+            </a:extLst>
+          </a:blip>
+          <a:stretch>
+            <a:fillRect/>
+          </a:stretch>
+        </p:blipFill>
+        <p:spPr>
+          <a:xfrm>
+            <a:off x="762000" y="1854200"/>
+            <a:ext cx="10668000" cy="2730500"/>
+          </a:xfrm>
+          <a:prstGeom prst="rect">
+            <a:avLst/>
+          </a:prstGeom>
+        </p:spPr>
+      </p:pic>
+    </p:spTree>
+    <p:extLst>
+      <p:ext uri="{BB962C8B-B14F-4D97-AF65-F5344CB8AC3E}">
+        <p14:creationId xmlns:p14="http://schemas.microsoft.com/office/powerpoint/2010/main" val="2763541281"/>
+      </p:ext>
+    </p:extLst>
+  </p:cSld>
+  <p:clrMapOvr>
+    <a:masterClrMapping/>
+  </p:clrMapOvr>
+  <p:timing>
+    <p:tnLst>
+      <p:par>
+        <p:cTn id="1" dur="indefinite" restart="never" nodeType="tmRoot">
+          <p:childTnLst>
+            <p:seq concurrent="1" nextAc="seek">
+              <p:cTn id="2" dur="indefinite" nodeType="mainSeq">
+                <p:childTnLst>
+                  <p:par>
+                    <p:cTn id="3" fill="hold">
+                      <p:stCondLst>
+                        <p:cond delay="indefinite"/>
+                      </p:stCondLst>
+                      <p:childTnLst>
+                        <p:par>
+                          <p:cTn id="4" fill="hold">
+                            <p:stCondLst>
+                              <p:cond delay="0"/>
+                            </p:stCondLst>
+                            <p:childTnLst>
+                              <p:par>
+                                <p:cTn id="5" presetID="34" presetClass="entr" presetSubtype="0" fill="hold" grpId="0" nodeType="clickEffect">
+                                  <p:stCondLst>
+                                    <p:cond delay="0"/>
+                                  </p:stCondLst>
+                                  <p:childTnLst>
+                                    <p:set>
+                                      <p:cBhvr>
+                                        <p:cTn id="6" dur="1" fill="hold">
+                                          <p:stCondLst>
+                                            <p:cond delay="0"/>
+                                          </p:stCondLst>
+                                        </p:cTn>
+                                        <p:tgtEl>
+                                          <p:spTgt spid="6"/>
+                                        </p:tgtEl>
+                                        <p:attrNameLst>
+                                          <p:attrName>style.visibility</p:attrName>
+                                        </p:attrNameLst>
+                                      </p:cBhvr>
+                                      <p:to>
+                                        <p:strVal val="visible"/>
+                                      </p:to>
+                                    </p:set>
+                                    <p:anim from="(-#ppt_w/2)" to="(#ppt_x)" calcmode="lin" valueType="num">
+                                      <p:cBhvr>
+                                        <p:cTn id="7" dur="600" fill="hold">
+                                          <p:stCondLst>
+                                            <p:cond delay="0"/>
+                                          </p:stCondLst>
+                                        </p:cTn>
+                                        <p:tgtEl>
+                                          <p:spTgt spid="6"/>
+                                        </p:tgtEl>
+                                        <p:attrNameLst>
+                                          <p:attrName>ppt_x</p:attrName>
+                                        </p:attrNameLst>
+                                      </p:cBhvr>
+                                    </p:anim>
+                                    <p:anim from="0" to="-1.0" calcmode="lin" valueType="num">
+                                      <p:cBhvr>
+                                        <p:cTn id="8" dur="200" decel="50000" autoRev="1" fill="hold">
+                                          <p:stCondLst>
+                                            <p:cond delay="600"/>
+                                          </p:stCondLst>
+                                        </p:cTn>
+                                        <p:tgtEl>
+                                          <p:spTgt spid="6"/>
+                                        </p:tgtEl>
+                                        <p:attrNameLst>
+                                          <p:attrName>xshear</p:attrName>
+                                        </p:attrNameLst>
+                                      </p:cBhvr>
+                                    </p:anim>
+                                    <p:animScale>
+                                      <p:cBhvr>
+                                        <p:cTn id="9" dur="200" decel="100000" autoRev="1" fill="hold">
+                                          <p:stCondLst>
+                                            <p:cond delay="600"/>
+                                          </p:stCondLst>
+                                        </p:cTn>
+                                        <p:tgtEl>
+                                          <p:spTgt spid="6"/>
+                                        </p:tgtEl>
+                                      </p:cBhvr>
+                                      <p:from x="100000" y="100000"/>
+                                      <p:to x="80000" y="100000"/>
+                                    </p:animScale>
+                                    <p:anim by="(#ppt_h/3+#ppt_w*0.1)" calcmode="lin" valueType="num">
+                                      <p:cBhvr additive="sum">
+                                        <p:cTn id="10" dur="200" decel="100000" autoRev="1" fill="hold">
+                                          <p:stCondLst>
+                                            <p:cond delay="600"/>
+                                          </p:stCondLst>
+                                        </p:cTn>
+                                        <p:tgtEl>
+                                          <p:spTgt spid="6"/>
+                                        </p:tgtEl>
+                                        <p:attrNameLst>
+                                          <p:attrName>ppt_x</p:attrName>
+                                        </p:attrNameLst>
+                                      </p:cBhvr>
+                                    </p:anim>
+                                  </p:childTnLst>
+                                </p:cTn>
+                              </p:par>
+                            </p:childTnLst>
+                          </p:cTn>
+                        </p:par>
+                      </p:childTnLst>
+                    </p:cTn>
+                  </p:par>
+                  <p:par>
+                    <p:cTn id="11" fill="hold">
+                      <p:stCondLst>
+                        <p:cond delay="indefinite"/>
+                      </p:stCondLst>
+                      <p:childTnLst>
+                        <p:par>
+                          <p:cTn id="12" fill="hold">
+                            <p:stCondLst>
+                              <p:cond delay="0"/>
+                            </p:stCondLst>
+                            <p:childTnLst>
+                              <p:par>
+                                <p:cTn id="13" presetID="34" presetClass="entr" presetSubtype="0" fill="hold" grpId="0" nodeType="clickEffect">
+                                  <p:stCondLst>
+                                    <p:cond delay="0"/>
+                                  </p:stCondLst>
+                                  <p:childTnLst>
+                                    <p:set>
+                                      <p:cBhvr>
+                                        <p:cTn id="14" dur="1" fill="hold">
+                                          <p:stCondLst>
+                                            <p:cond delay="0"/>
+                                          </p:stCondLst>
+                                        </p:cTn>
+                                        <p:tgtEl>
+                                          <p:spTgt spid="8"/>
+                                        </p:tgtEl>
+                                        <p:attrNameLst>
+                                          <p:attrName>style.visibility</p:attrName>
+                                        </p:attrNameLst>
+                                      </p:cBhvr>
+                                      <p:to>
+                                        <p:strVal val="visible"/>
+                                      </p:to>
+                                    </p:set>
+                                    <p:anim from="(-#ppt_w/2)" to="(#ppt_x)" calcmode="lin" valueType="num">
+                                      <p:cBhvr>
+                                        <p:cTn id="15" dur="600" fill="hold">
+                                          <p:stCondLst>
+                                            <p:cond delay="0"/>
+                                          </p:stCondLst>
+                                        </p:cTn>
+                                        <p:tgtEl>
+                                          <p:spTgt spid="8"/>
+                                        </p:tgtEl>
+                                        <p:attrNameLst>
+                                          <p:attrName>ppt_x</p:attrName>
+                                        </p:attrNameLst>
+                                      </p:cBhvr>
+                                    </p:anim>
+                                    <p:anim from="0" to="-1.0" calcmode="lin" valueType="num">
+                                      <p:cBhvr>
+                                        <p:cTn id="16" dur="200" decel="50000" autoRev="1" fill="hold">
+                                          <p:stCondLst>
+                                            <p:cond delay="600"/>
+                                          </p:stCondLst>
+                                        </p:cTn>
+                                        <p:tgtEl>
+                                          <p:spTgt spid="8"/>
+                                        </p:tgtEl>
+                                        <p:attrNameLst>
+                                          <p:attrName>xshear</p:attrName>
+                                        </p:attrNameLst>
+                                      </p:cBhvr>
+                                    </p:anim>
+                                    <p:animScale>
+                                      <p:cBhvr>
+                                        <p:cTn id="17" dur="200" decel="100000" autoRev="1" fill="hold">
+                                          <p:stCondLst>
+                                            <p:cond delay="600"/>
+                                          </p:stCondLst>
+                                        </p:cTn>
+                                        <p:tgtEl>
+                                          <p:spTgt spid="8"/>
+                                        </p:tgtEl>
+                                      </p:cBhvr>
+                                      <p:from x="100000" y="100000"/>
+                                      <p:to x="80000" y="100000"/>
+                                    </p:animScale>
+                                    <p:anim by="(#ppt_h/3+#ppt_w*0.1)" calcmode="lin" valueType="num">
+                                      <p:cBhvr additive="sum">
+                                        <p:cTn id="18" dur="200" decel="100000" autoRev="1" fill="hold">
+                                          <p:stCondLst>
+                                            <p:cond delay="600"/>
+                                          </p:stCondLst>
+                                        </p:cTn>
+                                        <p:tgtEl>
+                                          <p:spTgt spid="8"/>
+                                        </p:tgtEl>
+                                        <p:attrNameLst>
+                                          <p:attrName>ppt_x</p:attrName>
+                                        </p:attrNameLst>
+                                      </p:cBhvr>
+                                    </p:anim>
+                                  </p:childTnLst>
+                                </p:cTn>
+                              </p:par>
+                            </p:childTnLst>
+                          </p:cTn>
+                        </p:par>
+                      </p:childTnLst>
+                    </p:cTn>
+                  </p:par>
+                </p:childTnLst>
+              </p:cTn>
+              <p:prevCondLst>
+                <p:cond evt="onPrev" delay="0">
+                  <p:tgtEl>
+                    <p:sldTgt/>
+                  </p:tgtEl>
+                </p:cond>
+              </p:prevCondLst>
+              <p:nextCondLst>
+                <p:cond evt="onNext" delay="0">
+                  <p:tgtEl>
+                    <p:sldTgt/>
+                  </p:tgtEl>
+                </p:cond>
+              </p:nextCondLst>
+            </p:seq>
+          </p:childTnLst>
+        </p:cTn>
+      </p:par>
+    </p:tnLst>
+    <p:bldLst>
+      <p:bldP spid="6" grpId="0"/>
+      <p:bldP spid="8" grpId="0"/>
+    </p:bldLst>
+  </p:timing>
+</p:sld>
+</file>
+
+<file path=ppt/slides/slide12.xml><?xml version="1.0" encoding="utf-8"?>
+<p:sld xmlns:a="http://schemas.openxmlformats.org/drawingml/2006/main" xmlns:r="http://schemas.openxmlformats.org/officeDocument/2006/relationships" xmlns:p="http://schemas.openxmlformats.org/presentationml/2006/main">
+  <p:cSld>
+    <p:spTree>
+      <p:nvGrpSpPr>
+        <p:cNvPr id="1" name=""/>
+        <p:cNvGrpSpPr/>
+        <p:nvPr/>
+      </p:nvGrpSpPr>
+      <p:grpSpPr>
+        <a:xfrm>
+          <a:off x="0" y="0"/>
+          <a:ext cx="0" cy="0"/>
+          <a:chOff x="0" y="0"/>
+          <a:chExt cx="0" cy="0"/>
+        </a:xfrm>
+      </p:grpSpPr>
+      <p:sp>
+        <p:nvSpPr>
+          <p:cNvPr id="2" name="Title 1">
+            <a:extLst>
+              <a:ext uri="{FF2B5EF4-FFF2-40B4-BE49-F238E27FC236}">
+                <a16:creationId xmlns:a16="http://schemas.microsoft.com/office/drawing/2014/main" id="{D617AB41-6AD1-9EF2-7F95-46A904399681}"/>
+              </a:ext>
+            </a:extLst>
+          </p:cNvPr>
+          <p:cNvSpPr>
+            <a:spLocks noGrp="1"/>
+          </p:cNvSpPr>
+          <p:nvPr>
+            <p:ph type="title"/>
+          </p:nvPr>
+        </p:nvSpPr>
+        <p:spPr/>
+        <p:txBody>
+          <a:bodyPr>
+            <a:noAutofit/>
+          </a:bodyPr>
+          <a:lstStyle/>
+          <a:p>
+            <a:r>
+              <a:rPr lang="en-US">
+                <a:solidFill>
+                  <a:srgbClr val="1F3864"/>
+                </a:solidFill>
+              </a:rPr>
+              <a:t>The normal as a continuous distribution</a:t>
+            </a:r>
+          </a:p>
+        </p:txBody>
+      </p:sp>
+      <p:sp>
+        <p:nvSpPr>
+          <p:cNvPr id="4" name="Slide Number Placeholder 3">
+            <a:extLst>
+              <a:ext uri="{FF2B5EF4-FFF2-40B4-BE49-F238E27FC236}">
+                <a16:creationId xmlns:a16="http://schemas.microsoft.com/office/drawing/2014/main" id="{97D44AE5-98B5-B840-6B8A-D345C7C2E2F0}"/>
+              </a:ext>
+            </a:extLst>
+          </p:cNvPr>
+          <p:cNvSpPr>
+            <a:spLocks noGrp="1"/>
+          </p:cNvSpPr>
+          <p:nvPr>
+            <p:ph type="sldNum" sz="quarter" idx="12"/>
+          </p:nvPr>
+        </p:nvSpPr>
+        <p:spPr/>
+        <p:txBody>
+          <a:bodyPr/>
+          <a:lstStyle/>
+          <a:p>
+            <a:fld id="{A80A81DD-F10A-4B1C-963A-0ABBB4865886}" type="slidenum">
+              <a:rPr lang="en-US" sz="1600" smtClean="0"/>
+              <a:t>12</a:t>
+            </a:fld>
+            <a:endParaRPr lang="en-US" sz="1600"/>
+          </a:p>
+        </p:txBody>
+      </p:sp>
+      <p:sp>
+        <p:nvSpPr>
+          <p:cNvPr id="5" name="TextBox 4">
+            <a:extLst>
+              <a:ext uri="{FF2B5EF4-FFF2-40B4-BE49-F238E27FC236}">
+                <a16:creationId xmlns:a16="http://schemas.microsoft.com/office/drawing/2014/main" id="{A34AAE17-27CE-D7A3-C663-11BB48ACBF5B}"/>
+              </a:ext>
+            </a:extLst>
+          </p:cNvPr>
+          <p:cNvSpPr txBox="1"/>
+          <p:nvPr/>
+        </p:nvSpPr>
+        <p:spPr>
+          <a:xfrm>
+            <a:off x="762000" y="1879600"/>
+            <a:ext cx="10668000" cy="345440"/>
+          </a:xfrm>
+          <a:prstGeom prst="rect">
+            <a:avLst/>
+          </a:prstGeom>
+          <a:noFill/>
+        </p:spPr>
+        <p:txBody>
+          <a:bodyPr vert="horz" wrap="square" rtlCol="0">
+            <a:spAutoFit/>
+          </a:bodyPr>
+          <a:lstStyle/>
+          <a:p>
+            <a:pPr marL="304800" indent="-304800"/>
+            <a:r>
+              <a:rPr lang="en-US" sz="1600">
+                <a:solidFill>
+                  <a:srgbClr val="000000"/>
+                </a:solidFill>
+              </a:rPr>
+              <a:t>X ~ N(</a:t>
+            </a:r>
+            <a:r>
+              <a:rPr lang="el-GR" sz="1600">
+                <a:solidFill>
+                  <a:srgbClr val="000000"/>
+                </a:solidFill>
+              </a:rPr>
+              <a:t>μ, σ)</a:t>
+            </a:r>
+            <a:endParaRPr lang="en-US" sz="1600">
+              <a:solidFill>
+                <a:srgbClr val="000000"/>
+              </a:solidFill>
+            </a:endParaRPr>
+          </a:p>
+        </p:txBody>
+      </p:sp>
+      <p:sp>
+        <p:nvSpPr>
+          <p:cNvPr id="6" name="TextBox 5">
+            <a:extLst>
+              <a:ext uri="{FF2B5EF4-FFF2-40B4-BE49-F238E27FC236}">
+                <a16:creationId xmlns:a16="http://schemas.microsoft.com/office/drawing/2014/main" id="{E410A0F8-5E1E-9A1D-B64C-50827EE6C9B2}"/>
+              </a:ext>
+            </a:extLst>
+          </p:cNvPr>
+          <p:cNvSpPr txBox="1"/>
+          <p:nvPr/>
+        </p:nvSpPr>
+        <p:spPr>
+          <a:xfrm>
+            <a:off x="1117600" y="2225040"/>
+            <a:ext cx="10312400" cy="338554"/>
+          </a:xfrm>
+          <a:prstGeom prst="rect">
+            <a:avLst/>
+          </a:prstGeom>
+          <a:noFill/>
+        </p:spPr>
+        <p:txBody>
+          <a:bodyPr vert="horz" wrap="square" rtlCol="0">
+            <a:spAutoFit/>
+          </a:bodyPr>
+          <a:lstStyle/>
+          <a:p>
+            <a:r>
+              <a:rPr lang="en-US" sz="1600" b="1">
+                <a:solidFill>
+                  <a:srgbClr val="C00000"/>
+                </a:solidFill>
+              </a:rPr>
+              <a:t>a continuous random variable: it can take any value, and its density curve is the bell curve</a:t>
+            </a:r>
+          </a:p>
+        </p:txBody>
+      </p:sp>
+      <p:sp>
+        <p:nvSpPr>
+          <p:cNvPr id="7" name="TextBox 6">
+            <a:extLst>
+              <a:ext uri="{FF2B5EF4-FFF2-40B4-BE49-F238E27FC236}">
+                <a16:creationId xmlns:a16="http://schemas.microsoft.com/office/drawing/2014/main" id="{47D3CD95-D52E-5227-B663-7C0A72677B6E}"/>
+              </a:ext>
+            </a:extLst>
+          </p:cNvPr>
+          <p:cNvSpPr txBox="1"/>
+          <p:nvPr/>
+        </p:nvSpPr>
+        <p:spPr>
+          <a:xfrm>
+            <a:off x="762000" y="2741394"/>
+            <a:ext cx="10668000" cy="345440"/>
+          </a:xfrm>
+          <a:prstGeom prst="rect">
+            <a:avLst/>
+          </a:prstGeom>
+          <a:noFill/>
+        </p:spPr>
+        <p:txBody>
+          <a:bodyPr vert="horz" wrap="square" rtlCol="0">
+            <a:spAutoFit/>
+          </a:bodyPr>
+          <a:lstStyle/>
+          <a:p>
+            <a:pPr marL="304800" indent="-304800"/>
+            <a:r>
+              <a:rPr lang="en-US" sz="1600">
+                <a:solidFill>
+                  <a:srgbClr val="000000"/>
+                </a:solidFill>
+              </a:rPr>
+              <a:t>probability is area</a:t>
+            </a:r>
+          </a:p>
+        </p:txBody>
+      </p:sp>
+      <p:sp>
+        <p:nvSpPr>
+          <p:cNvPr id="8" name="TextBox 7">
+            <a:extLst>
+              <a:ext uri="{FF2B5EF4-FFF2-40B4-BE49-F238E27FC236}">
+                <a16:creationId xmlns:a16="http://schemas.microsoft.com/office/drawing/2014/main" id="{1CE3E601-601D-C6B1-8265-C079CB8C9269}"/>
+              </a:ext>
+            </a:extLst>
+          </p:cNvPr>
+          <p:cNvSpPr txBox="1"/>
+          <p:nvPr/>
+        </p:nvSpPr>
+        <p:spPr>
+          <a:xfrm>
+            <a:off x="1117600" y="3086834"/>
+            <a:ext cx="10312400" cy="338554"/>
+          </a:xfrm>
+          <a:prstGeom prst="rect">
+            <a:avLst/>
+          </a:prstGeom>
+          <a:noFill/>
+        </p:spPr>
+        <p:txBody>
+          <a:bodyPr vert="horz" wrap="square" rtlCol="0">
+            <a:spAutoFit/>
+          </a:bodyPr>
+          <a:lstStyle/>
+          <a:p>
+            <a:r>
+              <a:rPr lang="en-US" sz="1600" b="1">
+                <a:solidFill>
+                  <a:srgbClr val="C00000"/>
+                </a:solidFill>
+              </a:rPr>
+              <a:t>P(a &lt; X &lt; b) is the area under the curve between a and b;  the height is not a probability</a:t>
+            </a:r>
+          </a:p>
+        </p:txBody>
+      </p:sp>
+      <p:sp>
+        <p:nvSpPr>
+          <p:cNvPr id="9" name="TextBox 8">
+            <a:extLst>
+              <a:ext uri="{FF2B5EF4-FFF2-40B4-BE49-F238E27FC236}">
+                <a16:creationId xmlns:a16="http://schemas.microsoft.com/office/drawing/2014/main" id="{FB002BF4-8037-2F73-E27A-7A453477E389}"/>
+              </a:ext>
+            </a:extLst>
+          </p:cNvPr>
+          <p:cNvSpPr txBox="1"/>
+          <p:nvPr/>
+        </p:nvSpPr>
+        <p:spPr>
+          <a:xfrm>
+            <a:off x="762000" y="3603188"/>
+            <a:ext cx="10668000" cy="345440"/>
+          </a:xfrm>
+          <a:prstGeom prst="rect">
+            <a:avLst/>
+          </a:prstGeom>
+          <a:noFill/>
+        </p:spPr>
+        <p:txBody>
+          <a:bodyPr vert="horz" wrap="square" rtlCol="0">
+            <a:spAutoFit/>
+          </a:bodyPr>
+          <a:lstStyle/>
+          <a:p>
+            <a:pPr marL="304800" indent="-304800"/>
+            <a:r>
+              <a:rPr lang="en-US" sz="1600">
+                <a:solidFill>
+                  <a:srgbClr val="000000"/>
+                </a:solidFill>
+              </a:rPr>
+              <a:t>P(X = c) = 0</a:t>
+            </a:r>
+          </a:p>
+        </p:txBody>
+      </p:sp>
+      <p:sp>
+        <p:nvSpPr>
+          <p:cNvPr id="10" name="TextBox 9">
+            <a:extLst>
+              <a:ext uri="{FF2B5EF4-FFF2-40B4-BE49-F238E27FC236}">
+                <a16:creationId xmlns:a16="http://schemas.microsoft.com/office/drawing/2014/main" id="{10F3B3E3-D27C-E008-C93E-ED70BD2A4754}"/>
+              </a:ext>
+            </a:extLst>
+          </p:cNvPr>
+          <p:cNvSpPr txBox="1"/>
+          <p:nvPr/>
+        </p:nvSpPr>
+        <p:spPr>
+          <a:xfrm>
+            <a:off x="1117600" y="3948628"/>
+            <a:ext cx="10312400" cy="338554"/>
+          </a:xfrm>
+          <a:prstGeom prst="rect">
+            <a:avLst/>
+          </a:prstGeom>
+          <a:noFill/>
+        </p:spPr>
+        <p:txBody>
+          <a:bodyPr vert="horz" wrap="square" rtlCol="0">
+            <a:spAutoFit/>
+          </a:bodyPr>
+          <a:lstStyle/>
+          <a:p>
+            <a:r>
+              <a:rPr lang="en-US" sz="1600" b="1">
+                <a:solidFill>
+                  <a:srgbClr val="C00000"/>
+                </a:solidFill>
+              </a:rPr>
+              <a:t>a single value has no width, so P(X &lt; c) = P(X ≤ c)</a:t>
+            </a:r>
+            <a:endParaRPr lang="en-US" sz="1600" b="1" dirty="0">
+              <a:solidFill>
+                <a:srgbClr val="C00000"/>
+              </a:solidFill>
+            </a:endParaRPr>
+          </a:p>
+        </p:txBody>
+      </p:sp>
+      <p:sp>
+        <p:nvSpPr>
+          <p:cNvPr id="3" name="Title rule">
+            <a:extLst>
+              <a:ext uri="{FF2B5EF4-FFF2-40B4-BE49-F238E27FC236}">
+                <a16:creationId xmlns:a16="http://schemas.microsoft.com/office/drawing/2014/main" id="{B469CAAB-2B69-6863-7C28-0C5959E5734B}"/>
+              </a:ext>
+            </a:extLst>
+          </p:cNvPr>
+          <p:cNvSpPr/>
+          <p:nvPr/>
+        </p:nvSpPr>
+        <p:spPr>
+          <a:xfrm>
+            <a:off x="838200" y="1600200"/>
+            <a:ext cx="10515600" cy="38100"/>
+          </a:xfrm>
+          <a:prstGeom prst="rect">
+            <a:avLst/>
+          </a:prstGeom>
+          <a:solidFill>
+            <a:srgbClr val="4472C4"/>
+          </a:solidFill>
+          <a:ln w="12700" cap="flat" cmpd="sng" algn="ctr">
+            <a:noFill/>
+            <a:prstDash val="solid"/>
+            <a:miter lim="800000"/>
+          </a:ln>
+          <a:effectLst/>
+          <a:extLst>
+            <a:ext uri="{91240B29-F687-4F45-9708-019B960494DF}">
+              <a14:hiddenLine xmlns:a14="http://schemas.microsoft.com/office/drawing/2010/main" w="12700" cap="flat" cmpd="sng" algn="ctr">
+                <a:solidFill>
+                  <a:schemeClr val="accent1">
+                    <a:shade val="15000"/>
+                  </a:schemeClr>
+                </a:solidFill>
+                <a:prstDash val="solid"/>
+                <a:miter lim="800000"/>
+              </a14:hiddenLine>
+            </a:ext>
+          </a:extLst>
+        </p:spPr>
+        <p:style>
+          <a:lnRef idx="2">
+            <a:schemeClr val="accent1">
+              <a:shade val="15000"/>
+            </a:schemeClr>
+          </a:lnRef>
+          <a:fillRef idx="1">
+            <a:schemeClr val="accent1"/>
+          </a:fillRef>
+          <a:effectRef idx="0">
+            <a:schemeClr val="accent1"/>
+          </a:effectRef>
+          <a:fontRef idx="minor">
+            <a:schemeClr val="lt1"/>
+          </a:fontRef>
+        </p:style>
+        <p:txBody>
+          <a:bodyPr rtlCol="0" anchor="ctr"/>
+          <a:lstStyle/>
+          <a:p>
+            <a:pPr algn="ctr"/>
+            <a:endParaRPr lang="en-US"/>
+          </a:p>
+        </p:txBody>
+      </p:sp>
+    </p:spTree>
+    <p:extLst>
+      <p:ext uri="{BB962C8B-B14F-4D97-AF65-F5344CB8AC3E}">
+        <p14:creationId xmlns:p14="http://schemas.microsoft.com/office/powerpoint/2010/main" val="3867227488"/>
+      </p:ext>
+    </p:extLst>
+  </p:cSld>
+  <p:clrMapOvr>
+    <a:masterClrMapping/>
+  </p:clrMapOvr>
+  <p:timing>
+    <p:tnLst>
+      <p:par>
+        <p:cTn id="1" dur="indefinite" restart="never" nodeType="tmRoot">
+          <p:childTnLst>
+            <p:seq concurrent="1" nextAc="seek">
+              <p:cTn id="2" dur="indefinite" nodeType="mainSeq">
+                <p:childTnLst>
+                  <p:par>
+                    <p:cTn id="3" fill="hold">
+                      <p:stCondLst>
+                        <p:cond delay="indefinite"/>
+                      </p:stCondLst>
+                      <p:childTnLst>
+                        <p:par>
+                          <p:cTn id="4" fill="hold">
+                            <p:stCondLst>
+                              <p:cond delay="0"/>
+                            </p:stCondLst>
+                            <p:childTnLst>
+                              <p:par>
+                                <p:cTn id="5" presetID="34" presetClass="entr" presetSubtype="0" fill="hold" grpId="0" nodeType="clickEffect">
+                                  <p:stCondLst>
+                                    <p:cond delay="0"/>
+                                  </p:stCondLst>
+                                  <p:childTnLst>
+                                    <p:set>
+                                      <p:cBhvr>
+                                        <p:cTn id="6" dur="1" fill="hold">
+                                          <p:stCondLst>
+                                            <p:cond delay="0"/>
+                                          </p:stCondLst>
+                                        </p:cTn>
+                                        <p:tgtEl>
+                                          <p:spTgt spid="6"/>
+                                        </p:tgtEl>
+                                        <p:attrNameLst>
+                                          <p:attrName>style.visibility</p:attrName>
+                                        </p:attrNameLst>
+                                      </p:cBhvr>
+                                      <p:to>
+                                        <p:strVal val="visible"/>
+                                      </p:to>
+                                    </p:set>
+                                    <p:anim from="(-#ppt_w/2)" to="(#ppt_x)" calcmode="lin" valueType="num">
+                                      <p:cBhvr>
+                                        <p:cTn id="7" dur="600" fill="hold">
+                                          <p:stCondLst>
+                                            <p:cond delay="0"/>
+                                          </p:stCondLst>
+                                        </p:cTn>
+                                        <p:tgtEl>
+                                          <p:spTgt spid="6"/>
+                                        </p:tgtEl>
+                                        <p:attrNameLst>
+                                          <p:attrName>ppt_x</p:attrName>
+                                        </p:attrNameLst>
+                                      </p:cBhvr>
+                                    </p:anim>
+                                    <p:anim from="0" to="-1.0" calcmode="lin" valueType="num">
+                                      <p:cBhvr>
+                                        <p:cTn id="8" dur="200" decel="50000" autoRev="1" fill="hold">
+                                          <p:stCondLst>
+                                            <p:cond delay="600"/>
+                                          </p:stCondLst>
+                                        </p:cTn>
+                                        <p:tgtEl>
+                                          <p:spTgt spid="6"/>
+                                        </p:tgtEl>
+                                        <p:attrNameLst>
+                                          <p:attrName>xshear</p:attrName>
+                                        </p:attrNameLst>
+                                      </p:cBhvr>
+                                    </p:anim>
+                                    <p:animScale>
+                                      <p:cBhvr>
+                                        <p:cTn id="9" dur="200" decel="100000" autoRev="1" fill="hold">
+                                          <p:stCondLst>
+                                            <p:cond delay="600"/>
+                                          </p:stCondLst>
+                                        </p:cTn>
+                                        <p:tgtEl>
+                                          <p:spTgt spid="6"/>
+                                        </p:tgtEl>
+                                      </p:cBhvr>
+                                      <p:from x="100000" y="100000"/>
+                                      <p:to x="80000" y="100000"/>
+                                    </p:animScale>
+                                    <p:anim by="(#ppt_h/3+#ppt_w*0.1)" calcmode="lin" valueType="num">
+                                      <p:cBhvr additive="sum">
+                                        <p:cTn id="10" dur="200" decel="100000" autoRev="1" fill="hold">
+                                          <p:stCondLst>
+                                            <p:cond delay="600"/>
+                                          </p:stCondLst>
+                                        </p:cTn>
+                                        <p:tgtEl>
+                                          <p:spTgt spid="6"/>
+                                        </p:tgtEl>
+                                        <p:attrNameLst>
+                                          <p:attrName>ppt_x</p:attrName>
+                                        </p:attrNameLst>
+                                      </p:cBhvr>
+                                    </p:anim>
+                                  </p:childTnLst>
+                                </p:cTn>
+                              </p:par>
+                            </p:childTnLst>
+                          </p:cTn>
+                        </p:par>
+                      </p:childTnLst>
+                    </p:cTn>
+                  </p:par>
+                  <p:par>
+                    <p:cTn id="11" fill="hold">
+                      <p:stCondLst>
+                        <p:cond delay="indefinite"/>
+                      </p:stCondLst>
+                      <p:childTnLst>
+                        <p:par>
+                          <p:cTn id="12" fill="hold">
+                            <p:stCondLst>
+                              <p:cond delay="0"/>
+                            </p:stCondLst>
+                            <p:childTnLst>
+                              <p:par>
+                                <p:cTn id="13" presetID="34" presetClass="entr" presetSubtype="0" fill="hold" grpId="0" nodeType="clickEffect">
+                                  <p:stCondLst>
+                                    <p:cond delay="0"/>
+                                  </p:stCondLst>
+                                  <p:childTnLst>
+                                    <p:set>
+                                      <p:cBhvr>
+                                        <p:cTn id="14" dur="1" fill="hold">
+                                          <p:stCondLst>
+                                            <p:cond delay="0"/>
+                                          </p:stCondLst>
+                                        </p:cTn>
+                                        <p:tgtEl>
+                                          <p:spTgt spid="8"/>
+                                        </p:tgtEl>
+                                        <p:attrNameLst>
+                                          <p:attrName>style.visibility</p:attrName>
+                                        </p:attrNameLst>
+                                      </p:cBhvr>
+                                      <p:to>
+                                        <p:strVal val="visible"/>
+                                      </p:to>
+                                    </p:set>
+                                    <p:anim from="(-#ppt_w/2)" to="(#ppt_x)" calcmode="lin" valueType="num">
+                                      <p:cBhvr>
+                                        <p:cTn id="15" dur="600" fill="hold">
+                                          <p:stCondLst>
+                                            <p:cond delay="0"/>
+                                          </p:stCondLst>
+                                        </p:cTn>
+                                        <p:tgtEl>
+                                          <p:spTgt spid="8"/>
+                                        </p:tgtEl>
+                                        <p:attrNameLst>
+                                          <p:attrName>ppt_x</p:attrName>
+                                        </p:attrNameLst>
+                                      </p:cBhvr>
+                                    </p:anim>
+                                    <p:anim from="0" to="-1.0" calcmode="lin" valueType="num">
+                                      <p:cBhvr>
+                                        <p:cTn id="16" dur="200" decel="50000" autoRev="1" fill="hold">
+                                          <p:stCondLst>
+                                            <p:cond delay="600"/>
+                                          </p:stCondLst>
+                                        </p:cTn>
+                                        <p:tgtEl>
+                                          <p:spTgt spid="8"/>
+                                        </p:tgtEl>
+                                        <p:attrNameLst>
+                                          <p:attrName>xshear</p:attrName>
+                                        </p:attrNameLst>
+                                      </p:cBhvr>
+                                    </p:anim>
+                                    <p:animScale>
+                                      <p:cBhvr>
+                                        <p:cTn id="17" dur="200" decel="100000" autoRev="1" fill="hold">
+                                          <p:stCondLst>
+                                            <p:cond delay="600"/>
+                                          </p:stCondLst>
+                                        </p:cTn>
+                                        <p:tgtEl>
+                                          <p:spTgt spid="8"/>
+                                        </p:tgtEl>
+                                      </p:cBhvr>
+                                      <p:from x="100000" y="100000"/>
+                                      <p:to x="80000" y="100000"/>
+                                    </p:animScale>
+                                    <p:anim by="(#ppt_h/3+#ppt_w*0.1)" calcmode="lin" valueType="num">
+                                      <p:cBhvr additive="sum">
+                                        <p:cTn id="18" dur="200" decel="100000" autoRev="1" fill="hold">
+                                          <p:stCondLst>
+                                            <p:cond delay="600"/>
+                                          </p:stCondLst>
+                                        </p:cTn>
+                                        <p:tgtEl>
+                                          <p:spTgt spid="8"/>
+                                        </p:tgtEl>
+                                        <p:attrNameLst>
+                                          <p:attrName>ppt_x</p:attrName>
+                                        </p:attrNameLst>
+                                      </p:cBhvr>
+                                    </p:anim>
+                                  </p:childTnLst>
+                                </p:cTn>
+                              </p:par>
+                            </p:childTnLst>
+                          </p:cTn>
+                        </p:par>
+                      </p:childTnLst>
+                    </p:cTn>
+                  </p:par>
+                  <p:par>
+                    <p:cTn id="19" fill="hold">
+                      <p:stCondLst>
+                        <p:cond delay="indefinite"/>
+                      </p:stCondLst>
+                      <p:childTnLst>
+                        <p:par>
+                          <p:cTn id="20" fill="hold">
+                            <p:stCondLst>
+                              <p:cond delay="0"/>
+                            </p:stCondLst>
+                            <p:childTnLst>
+                              <p:par>
+                                <p:cTn id="21" presetID="34" presetClass="entr" presetSubtype="0" fill="hold" grpId="0" nodeType="clickEffect">
+                                  <p:stCondLst>
+                                    <p:cond delay="0"/>
+                                  </p:stCondLst>
+                                  <p:childTnLst>
+                                    <p:set>
+                                      <p:cBhvr>
+                                        <p:cTn id="22" dur="1" fill="hold">
+                                          <p:stCondLst>
+                                            <p:cond delay="0"/>
+                                          </p:stCondLst>
+                                        </p:cTn>
+                                        <p:tgtEl>
+                                          <p:spTgt spid="10"/>
+                                        </p:tgtEl>
+                                        <p:attrNameLst>
+                                          <p:attrName>style.visibility</p:attrName>
+                                        </p:attrNameLst>
+                                      </p:cBhvr>
+                                      <p:to>
+                                        <p:strVal val="visible"/>
+                                      </p:to>
+                                    </p:set>
+                                    <p:anim from="(-#ppt_w/2)" to="(#ppt_x)" calcmode="lin" valueType="num">
+                                      <p:cBhvr>
+                                        <p:cTn id="23" dur="600" fill="hold">
+                                          <p:stCondLst>
+                                            <p:cond delay="0"/>
+                                          </p:stCondLst>
+                                        </p:cTn>
+                                        <p:tgtEl>
+                                          <p:spTgt spid="10"/>
+                                        </p:tgtEl>
+                                        <p:attrNameLst>
+                                          <p:attrName>ppt_x</p:attrName>
+                                        </p:attrNameLst>
+                                      </p:cBhvr>
+                                    </p:anim>
+                                    <p:anim from="0" to="-1.0" calcmode="lin" valueType="num">
+                                      <p:cBhvr>
+                                        <p:cTn id="24" dur="200" decel="50000" autoRev="1" fill="hold">
+                                          <p:stCondLst>
+                                            <p:cond delay="600"/>
+                                          </p:stCondLst>
+                                        </p:cTn>
+                                        <p:tgtEl>
+                                          <p:spTgt spid="10"/>
+                                        </p:tgtEl>
+                                        <p:attrNameLst>
+                                          <p:attrName>xshear</p:attrName>
+                                        </p:attrNameLst>
+                                      </p:cBhvr>
+                                    </p:anim>
+                                    <p:animScale>
+                                      <p:cBhvr>
+                                        <p:cTn id="25" dur="200" decel="100000" autoRev="1" fill="hold">
+                                          <p:stCondLst>
+                                            <p:cond delay="600"/>
+                                          </p:stCondLst>
+                                        </p:cTn>
+                                        <p:tgtEl>
+                                          <p:spTgt spid="10"/>
+                                        </p:tgtEl>
+                                      </p:cBhvr>
+                                      <p:from x="100000" y="100000"/>
+                                      <p:to x="80000" y="100000"/>
+                                    </p:animScale>
+                                    <p:anim by="(#ppt_h/3+#ppt_w*0.1)" calcmode="lin" valueType="num">
+                                      <p:cBhvr additive="sum">
+                                        <p:cTn id="26" dur="200" decel="100000" autoRev="1" fill="hold">
+                                          <p:stCondLst>
+                                            <p:cond delay="600"/>
+                                          </p:stCondLst>
+                                        </p:cTn>
+                                        <p:tgtEl>
+                                          <p:spTgt spid="10"/>
+                                        </p:tgtEl>
+                                        <p:attrNameLst>
+                                          <p:attrName>ppt_x</p:attrName>
+                                        </p:attrNameLst>
+                                      </p:cBhvr>
+                                    </p:anim>
+                                  </p:childTnLst>
+                                </p:cTn>
+                              </p:par>
+                            </p:childTnLst>
+                          </p:cTn>
+                        </p:par>
+                      </p:childTnLst>
+                    </p:cTn>
+                  </p:par>
+                </p:childTnLst>
+              </p:cTn>
+              <p:prevCondLst>
+                <p:cond evt="onPrev" delay="0">
+                  <p:tgtEl>
+                    <p:sldTgt/>
+                  </p:tgtEl>
+                </p:cond>
+              </p:prevCondLst>
+              <p:nextCondLst>
+                <p:cond evt="onNext" delay="0">
+                  <p:tgtEl>
+                    <p:sldTgt/>
+                  </p:tgtEl>
+                </p:cond>
+              </p:nextCondLst>
+            </p:seq>
+          </p:childTnLst>
+        </p:cTn>
+      </p:par>
+    </p:tnLst>
+    <p:bldLst>
+      <p:bldP spid="6" grpId="0"/>
+      <p:bldP spid="8" grpId="0"/>
+      <p:bldP spid="10" grpId="0"/>
+    </p:bldLst>
+  </p:timing>
+</p:sld>
+</file>
+
+<file path=ppt/slides/slide13.xml><?xml version="1.0" encoding="utf-8"?>
+<p:sld xmlns:a="http://schemas.openxmlformats.org/drawingml/2006/main" xmlns:r="http://schemas.openxmlformats.org/officeDocument/2006/relationships" xmlns:p="http://schemas.openxmlformats.org/presentationml/2006/main">
+  <p:cSld>
+    <p:spTree>
+      <p:nvGrpSpPr>
+        <p:cNvPr id="1" name=""/>
+        <p:cNvGrpSpPr/>
+        <p:nvPr/>
+      </p:nvGrpSpPr>
+      <p:grpSpPr>
+        <a:xfrm>
+          <a:off x="0" y="0"/>
+          <a:ext cx="0" cy="0"/>
+          <a:chOff x="0" y="0"/>
+          <a:chExt cx="0" cy="0"/>
+        </a:xfrm>
+      </p:grpSpPr>
+      <p:sp>
+        <p:nvSpPr>
+          <p:cNvPr id="2" name="Title 1">
+            <a:extLst>
+              <a:ext uri="{FF2B5EF4-FFF2-40B4-BE49-F238E27FC236}">
+                <a16:creationId xmlns:a16="http://schemas.microsoft.com/office/drawing/2014/main" id="{D617AB41-6AD1-9EF2-7F95-46A904399681}"/>
+              </a:ext>
+            </a:extLst>
+          </p:cNvPr>
+          <p:cNvSpPr>
+            <a:spLocks noGrp="1"/>
+          </p:cNvSpPr>
+          <p:nvPr>
+            <p:ph type="title"/>
+          </p:nvPr>
+        </p:nvSpPr>
+        <p:spPr/>
+        <p:txBody>
+          <a:bodyPr>
+            <a:noAutofit/>
+          </a:bodyPr>
+          <a:lstStyle/>
+          <a:p>
+            <a:r>
+              <a:rPr lang="en-US">
+                <a:solidFill>
+                  <a:srgbClr val="1F3864"/>
+                </a:solidFill>
+              </a:rPr>
+              <a:t>Cumulative probability</a:t>
+            </a:r>
+          </a:p>
+        </p:txBody>
+      </p:sp>
+      <p:sp>
+        <p:nvSpPr>
+          <p:cNvPr id="4" name="Slide Number Placeholder 3">
+            <a:extLst>
+              <a:ext uri="{FF2B5EF4-FFF2-40B4-BE49-F238E27FC236}">
+                <a16:creationId xmlns:a16="http://schemas.microsoft.com/office/drawing/2014/main" id="{97D44AE5-98B5-B840-6B8A-D345C7C2E2F0}"/>
+              </a:ext>
+            </a:extLst>
+          </p:cNvPr>
+          <p:cNvSpPr>
+            <a:spLocks noGrp="1"/>
+          </p:cNvSpPr>
+          <p:nvPr>
+            <p:ph type="sldNum" sz="quarter" idx="12"/>
+          </p:nvPr>
+        </p:nvSpPr>
+        <p:spPr/>
+        <p:txBody>
+          <a:bodyPr/>
+          <a:lstStyle/>
+          <a:p>
+            <a:fld id="{A80A81DD-F10A-4B1C-963A-0ABBB4865886}" type="slidenum">
+              <a:rPr lang="en-US" sz="1600" smtClean="0"/>
+              <a:t>13</a:t>
             </a:fld>
             <a:endParaRPr lang="en-US" sz="1600"/>
           </a:p>
@@ -4160,7 +5970,7 @@
 </p:sld>
 </file>
 
-<file path=ppt/slides/slide11.xml><?xml version="1.0" encoding="utf-8"?>
+<file path=ppt/slides/slide14.xml><?xml version="1.0" encoding="utf-8"?>
 <p:sld xmlns:a="http://schemas.openxmlformats.org/drawingml/2006/main" xmlns:r="http://schemas.openxmlformats.org/officeDocument/2006/relationships" xmlns:p="http://schemas.openxmlformats.org/presentationml/2006/main">
   <p:cSld>
     <p:spTree>
@@ -4234,7 +6044,7 @@
           <a:p>
             <a:fld id="{A80A81DD-F10A-4B1C-963A-0ABBB4865886}" type="slidenum">
               <a:rPr lang="en-US" sz="1600" smtClean="0"/>
-              <a:t>11</a:t>
+              <a:t>14</a:t>
             </a:fld>
             <a:endParaRPr lang="en-US" sz="1600"/>
           </a:p>
@@ -4653,7 +6463,7 @@
 </p:sld>
 </file>
 
-<file path=ppt/slides/slide12.xml><?xml version="1.0" encoding="utf-8"?>
+<file path=ppt/slides/slide15.xml><?xml version="1.0" encoding="utf-8"?>
 <p:sld xmlns:a="http://schemas.openxmlformats.org/drawingml/2006/main" xmlns:r="http://schemas.openxmlformats.org/officeDocument/2006/relationships" xmlns:p="http://schemas.openxmlformats.org/presentationml/2006/main">
   <p:cSld>
     <p:spTree>
@@ -4727,7 +6537,7 @@
           <a:p>
             <a:fld id="{A80A81DD-F10A-4B1C-963A-0ABBB4865886}" type="slidenum">
               <a:rPr lang="en-US" sz="1600" smtClean="0"/>
-              <a:t>12</a:t>
+              <a:t>15</a:t>
             </a:fld>
             <a:endParaRPr lang="en-US" sz="1600"/>
           </a:p>
@@ -7972,7 +9782,7 @@
           <p:cNvPr id="2" name="Title 1">
             <a:extLst>
               <a:ext uri="{FF2B5EF4-FFF2-40B4-BE49-F238E27FC236}">
-                <a16:creationId xmlns:a16="http://schemas.microsoft.com/office/drawing/2014/main" id="{D617AB41-6AD1-9EF2-7F95-46A904399681}"/>
+                <a16:creationId xmlns:a16="http://schemas.microsoft.com/office/drawing/2014/main" id="{C08D30B1-1864-30EF-7EAB-9BEE656C0012}"/>
               </a:ext>
             </a:extLst>
           </p:cNvPr>
@@ -7996,7 +9806,7 @@
                   <a:srgbClr val="1F3864"/>
                 </a:solidFill>
               </a:rPr>
-              <a:t>The Poisson distribution</a:t>
+              <a:t>Example: guessing on a quiz</a:t>
             </a:r>
           </a:p>
         </p:txBody>
@@ -8006,7 +9816,7 @@
           <p:cNvPr id="4" name="Slide Number Placeholder 3">
             <a:extLst>
               <a:ext uri="{FF2B5EF4-FFF2-40B4-BE49-F238E27FC236}">
-                <a16:creationId xmlns:a16="http://schemas.microsoft.com/office/drawing/2014/main" id="{97D44AE5-98B5-B840-6B8A-D345C7C2E2F0}"/>
+                <a16:creationId xmlns:a16="http://schemas.microsoft.com/office/drawing/2014/main" id="{3F875068-D051-44AE-498E-1BEBEDE3A7C8}"/>
               </a:ext>
             </a:extLst>
           </p:cNvPr>
@@ -8025,6 +9835,453 @@
             <a:fld id="{A80A81DD-F10A-4B1C-963A-0ABBB4865886}" type="slidenum">
               <a:rPr lang="en-US" sz="1600" smtClean="0"/>
               <a:t>6</a:t>
+            </a:fld>
+            <a:endParaRPr lang="en-US" sz="1600"/>
+          </a:p>
+        </p:txBody>
+      </p:sp>
+      <p:sp>
+        <p:nvSpPr>
+          <p:cNvPr id="3" name="Title rule">
+            <a:extLst>
+              <a:ext uri="{FF2B5EF4-FFF2-40B4-BE49-F238E27FC236}">
+                <a16:creationId xmlns:a16="http://schemas.microsoft.com/office/drawing/2014/main" id="{30656AA8-9645-F028-C769-A313710853CC}"/>
+              </a:ext>
+            </a:extLst>
+          </p:cNvPr>
+          <p:cNvSpPr/>
+          <p:nvPr/>
+        </p:nvSpPr>
+        <p:spPr>
+          <a:xfrm>
+            <a:off x="838200" y="1600200"/>
+            <a:ext cx="10515600" cy="38100"/>
+          </a:xfrm>
+          <a:prstGeom prst="rect">
+            <a:avLst/>
+          </a:prstGeom>
+          <a:solidFill>
+            <a:srgbClr val="4472C4"/>
+          </a:solidFill>
+          <a:ln w="12700" cap="flat" cmpd="sng" algn="ctr">
+            <a:noFill/>
+            <a:prstDash val="solid"/>
+            <a:miter lim="800000"/>
+          </a:ln>
+          <a:effectLst/>
+          <a:extLst>
+            <a:ext uri="{91240B29-F687-4F45-9708-019B960494DF}">
+              <a14:hiddenLine xmlns:a14="http://schemas.microsoft.com/office/drawing/2010/main" w="12700" cap="flat" cmpd="sng" algn="ctr">
+                <a:solidFill>
+                  <a:schemeClr val="accent1">
+                    <a:shade val="15000"/>
+                  </a:schemeClr>
+                </a:solidFill>
+                <a:prstDash val="solid"/>
+                <a:miter lim="800000"/>
+              </a14:hiddenLine>
+            </a:ext>
+          </a:extLst>
+        </p:spPr>
+        <p:style>
+          <a:lnRef idx="2">
+            <a:schemeClr val="accent1">
+              <a:shade val="15000"/>
+            </a:schemeClr>
+          </a:lnRef>
+          <a:fillRef idx="1">
+            <a:schemeClr val="accent1"/>
+          </a:fillRef>
+          <a:effectRef idx="0">
+            <a:schemeClr val="accent1"/>
+          </a:effectRef>
+          <a:fontRef idx="minor">
+            <a:schemeClr val="lt1"/>
+          </a:fontRef>
+        </p:style>
+        <p:txBody>
+          <a:bodyPr rtlCol="0" anchor="ctr"/>
+          <a:lstStyle/>
+          <a:p>
+            <a:pPr algn="ctr"/>
+            <a:endParaRPr lang="en-US"/>
+          </a:p>
+        </p:txBody>
+      </p:sp>
+      <p:sp>
+        <p:nvSpPr>
+          <p:cNvPr id="8" name="Context">
+            <a:extLst>
+              <a:ext uri="{FF2B5EF4-FFF2-40B4-BE49-F238E27FC236}">
+                <a16:creationId xmlns:a16="http://schemas.microsoft.com/office/drawing/2014/main" id="{71E3EA8C-31B4-DAD4-BC4A-65D72E59AD46}"/>
+              </a:ext>
+            </a:extLst>
+          </p:cNvPr>
+          <p:cNvSpPr txBox="1"/>
+          <p:nvPr/>
+        </p:nvSpPr>
+        <p:spPr>
+          <a:xfrm>
+            <a:off x="762000" y="1879600"/>
+            <a:ext cx="10668000" cy="381000"/>
+          </a:xfrm>
+          <a:prstGeom prst="rect">
+            <a:avLst/>
+          </a:prstGeom>
+          <a:noFill/>
+        </p:spPr>
+        <p:txBody>
+          <a:bodyPr vert="horz" wrap="square" rtlCol="0">
+            <a:spAutoFit/>
+          </a:bodyPr>
+          <a:lstStyle/>
+          <a:p>
+            <a:pPr>
+              <a:spcAft>
+                <a:spcPts val="200"/>
+              </a:spcAft>
+            </a:pPr>
+            <a:r>
+              <a:rPr lang="en-US">
+                <a:solidFill>
+                  <a:srgbClr val="000000"/>
+                </a:solidFill>
+                <a:latin typeface="Calibri" panose="020F0502020204030204" pitchFamily="34" charset="0"/>
+              </a:rPr>
+              <a:t>A student guesses on all 6 questions of a quiz; each has 4 options:  X ~ Binom(6, 0.25).</a:t>
+            </a:r>
+          </a:p>
+        </p:txBody>
+      </p:sp>
+      <p:sp>
+        <p:nvSpPr>
+          <p:cNvPr id="10" name="Question">
+            <a:extLst>
+              <a:ext uri="{FF2B5EF4-FFF2-40B4-BE49-F238E27FC236}">
+                <a16:creationId xmlns:a16="http://schemas.microsoft.com/office/drawing/2014/main" id="{B31E395F-B84E-D1E9-D22A-222467FC4105}"/>
+              </a:ext>
+            </a:extLst>
+          </p:cNvPr>
+          <p:cNvSpPr txBox="1"/>
+          <p:nvPr/>
+        </p:nvSpPr>
+        <p:spPr>
+          <a:xfrm>
+            <a:off x="762000" y="2286000"/>
+            <a:ext cx="10668000" cy="369332"/>
+          </a:xfrm>
+          <a:prstGeom prst="rect">
+            <a:avLst/>
+          </a:prstGeom>
+          <a:noFill/>
+        </p:spPr>
+        <p:txBody>
+          <a:bodyPr vert="horz" wrap="square" rtlCol="0">
+            <a:spAutoFit/>
+          </a:bodyPr>
+          <a:lstStyle/>
+          <a:p>
+            <a:pPr>
+              <a:spcAft>
+                <a:spcPts val="200"/>
+              </a:spcAft>
+            </a:pPr>
+            <a:r>
+              <a:rPr lang="en-US" b="1">
+                <a:solidFill>
+                  <a:srgbClr val="C00000"/>
+                </a:solidFill>
+                <a:latin typeface="Calibri" panose="020F0502020204030204" pitchFamily="34" charset="0"/>
+              </a:rPr>
+              <a:t>Use the bars:   (a)  P(X ≤ 1)?     (b)  P(X ≥ 3)?     (c)  P(1 ≤ X ≤ 3)?</a:t>
+            </a:r>
+          </a:p>
+        </p:txBody>
+      </p:sp>
+      <p:sp>
+        <p:nvSpPr>
+          <p:cNvPr id="11" name="Result">
+            <a:extLst>
+              <a:ext uri="{FF2B5EF4-FFF2-40B4-BE49-F238E27FC236}">
+                <a16:creationId xmlns:a16="http://schemas.microsoft.com/office/drawing/2014/main" id="{5A70F68E-0D93-07B8-82B2-4D8F2F681D0D}"/>
+              </a:ext>
+            </a:extLst>
+          </p:cNvPr>
+          <p:cNvSpPr/>
+          <p:nvPr/>
+        </p:nvSpPr>
+        <p:spPr>
+          <a:xfrm>
+            <a:off x="762000" y="5486400"/>
+            <a:ext cx="10668000" cy="787400"/>
+          </a:xfrm>
+          <a:prstGeom prst="roundRect">
+            <a:avLst>
+              <a:gd name="adj" fmla="val 4000"/>
+            </a:avLst>
+          </a:prstGeom>
+          <a:solidFill>
+            <a:srgbClr val="F2F6FC"/>
+          </a:solidFill>
+          <a:ln w="15875">
+            <a:solidFill>
+              <a:srgbClr val="4472C4"/>
+            </a:solidFill>
+          </a:ln>
+        </p:spPr>
+        <p:style>
+          <a:lnRef idx="2">
+            <a:schemeClr val="accent1">
+              <a:shade val="15000"/>
+            </a:schemeClr>
+          </a:lnRef>
+          <a:fillRef idx="1">
+            <a:schemeClr val="accent1"/>
+          </a:fillRef>
+          <a:effectRef idx="0">
+            <a:schemeClr val="accent1"/>
+          </a:effectRef>
+          <a:fontRef idx="minor">
+            <a:schemeClr val="lt1"/>
+          </a:fontRef>
+        </p:style>
+        <p:txBody>
+          <a:bodyPr wrap="square" lIns="152400" tIns="76200" rIns="152400" bIns="76200" rtlCol="0" anchor="ctr">
+            <a:spAutoFit/>
+          </a:bodyPr>
+          <a:lstStyle/>
+          <a:p>
+            <a:r>
+              <a:rPr lang="pt-BR" sz="2000" b="1">
+                <a:solidFill>
+                  <a:srgbClr val="C00000"/>
+                </a:solidFill>
+                <a:latin typeface="Calibri" panose="020F0502020204030204" pitchFamily="34" charset="0"/>
+              </a:rPr>
+              <a:t>(a)  0.178 + 0.356 = 0.534          (b)  1 − (0.178 + 0.356 + 0.297) = 0.169</a:t>
+            </a:r>
+          </a:p>
+          <a:p>
+            <a:r>
+              <a:rPr lang="pt-BR" sz="2000" b="1">
+                <a:solidFill>
+                  <a:srgbClr val="C00000"/>
+                </a:solidFill>
+                <a:latin typeface="Calibri" panose="020F0502020204030204" pitchFamily="34" charset="0"/>
+              </a:rPr>
+              <a:t>(c)  0.356 + 0.297 + 0.132 = 0.785</a:t>
+            </a:r>
+            <a:endParaRPr lang="en-US" sz="2000" b="1">
+              <a:solidFill>
+                <a:srgbClr val="C00000"/>
+              </a:solidFill>
+              <a:latin typeface="Calibri" panose="020F0502020204030204" pitchFamily="34" charset="0"/>
+            </a:endParaRPr>
+          </a:p>
+        </p:txBody>
+      </p:sp>
+      <p:pic>
+        <p:nvPicPr>
+          <p:cNvPr id="7" name="l17_binom_quiz.png">
+            <a:extLst>
+              <a:ext uri="{FF2B5EF4-FFF2-40B4-BE49-F238E27FC236}">
+                <a16:creationId xmlns:a16="http://schemas.microsoft.com/office/drawing/2014/main" id="{8EBA1959-4B20-83ED-57B5-5AB7DE4284C3}"/>
+              </a:ext>
+            </a:extLst>
+          </p:cNvPr>
+          <p:cNvPicPr>
+            <a:picLocks/>
+          </p:cNvPicPr>
+          <p:nvPr/>
+        </p:nvPicPr>
+        <p:blipFill>
+          <a:blip r:embed="rId2">
+            <a:extLst>
+              <a:ext uri="{28A0092B-C50C-407E-A947-70E740481C1C}">
+                <a14:useLocalDpi xmlns:a14="http://schemas.microsoft.com/office/drawing/2010/main" val="0"/>
+              </a:ext>
+            </a:extLst>
+          </a:blip>
+          <a:stretch>
+            <a:fillRect/>
+          </a:stretch>
+        </p:blipFill>
+        <p:spPr>
+          <a:xfrm>
+            <a:off x="2032000" y="2705100"/>
+            <a:ext cx="8128000" cy="2730500"/>
+          </a:xfrm>
+          <a:prstGeom prst="rect">
+            <a:avLst/>
+          </a:prstGeom>
+        </p:spPr>
+      </p:pic>
+    </p:spTree>
+    <p:extLst>
+      <p:ext uri="{BB962C8B-B14F-4D97-AF65-F5344CB8AC3E}">
+        <p14:creationId xmlns:p14="http://schemas.microsoft.com/office/powerpoint/2010/main" val="4251696502"/>
+      </p:ext>
+    </p:extLst>
+  </p:cSld>
+  <p:clrMapOvr>
+    <a:masterClrMapping/>
+  </p:clrMapOvr>
+  <p:timing>
+    <p:tnLst>
+      <p:par>
+        <p:cTn id="1" dur="indefinite" restart="never" nodeType="tmRoot">
+          <p:childTnLst>
+            <p:seq concurrent="1" nextAc="seek">
+              <p:cTn id="2" dur="indefinite" nodeType="mainSeq">
+                <p:childTnLst>
+                  <p:par>
+                    <p:cTn id="3" fill="hold">
+                      <p:stCondLst>
+                        <p:cond delay="indefinite"/>
+                      </p:stCondLst>
+                      <p:childTnLst>
+                        <p:par>
+                          <p:cTn id="4" fill="hold">
+                            <p:stCondLst>
+                              <p:cond delay="0"/>
+                            </p:stCondLst>
+                            <p:childTnLst>
+                              <p:par>
+                                <p:cTn id="5" presetID="1" presetClass="entr" presetSubtype="0" fill="hold" grpId="0" nodeType="clickEffect">
+                                  <p:stCondLst>
+                                    <p:cond delay="0"/>
+                                  </p:stCondLst>
+                                  <p:childTnLst>
+                                    <p:set>
+                                      <p:cBhvr>
+                                        <p:cTn id="6" dur="1" fill="hold">
+                                          <p:stCondLst>
+                                            <p:cond delay="0"/>
+                                          </p:stCondLst>
+                                        </p:cTn>
+                                        <p:tgtEl>
+                                          <p:spTgt spid="11"/>
+                                        </p:tgtEl>
+                                        <p:attrNameLst>
+                                          <p:attrName>style.visibility</p:attrName>
+                                        </p:attrNameLst>
+                                      </p:cBhvr>
+                                      <p:to>
+                                        <p:strVal val="visible"/>
+                                      </p:to>
+                                    </p:set>
+                                  </p:childTnLst>
+                                </p:cTn>
+                              </p:par>
+                            </p:childTnLst>
+                          </p:cTn>
+                        </p:par>
+                      </p:childTnLst>
+                    </p:cTn>
+                  </p:par>
+                </p:childTnLst>
+              </p:cTn>
+              <p:prevCondLst>
+                <p:cond evt="onPrev" delay="0">
+                  <p:tgtEl>
+                    <p:sldTgt/>
+                  </p:tgtEl>
+                </p:cond>
+              </p:prevCondLst>
+              <p:nextCondLst>
+                <p:cond evt="onNext" delay="0">
+                  <p:tgtEl>
+                    <p:sldTgt/>
+                  </p:tgtEl>
+                </p:cond>
+              </p:nextCondLst>
+            </p:seq>
+          </p:childTnLst>
+        </p:cTn>
+      </p:par>
+    </p:tnLst>
+    <p:bldLst>
+      <p:bldP spid="11" grpId="0" animBg="1"/>
+    </p:bldLst>
+  </p:timing>
+</p:sld>
+</file>
+
+<file path=ppt/slides/slide7.xml><?xml version="1.0" encoding="utf-8"?>
+<p:sld xmlns:a="http://schemas.openxmlformats.org/drawingml/2006/main" xmlns:r="http://schemas.openxmlformats.org/officeDocument/2006/relationships" xmlns:p="http://schemas.openxmlformats.org/presentationml/2006/main">
+  <p:cSld>
+    <p:spTree>
+      <p:nvGrpSpPr>
+        <p:cNvPr id="1" name=""/>
+        <p:cNvGrpSpPr/>
+        <p:nvPr/>
+      </p:nvGrpSpPr>
+      <p:grpSpPr>
+        <a:xfrm>
+          <a:off x="0" y="0"/>
+          <a:ext cx="0" cy="0"/>
+          <a:chOff x="0" y="0"/>
+          <a:chExt cx="0" cy="0"/>
+        </a:xfrm>
+      </p:grpSpPr>
+      <p:sp>
+        <p:nvSpPr>
+          <p:cNvPr id="2" name="Title 1">
+            <a:extLst>
+              <a:ext uri="{FF2B5EF4-FFF2-40B4-BE49-F238E27FC236}">
+                <a16:creationId xmlns:a16="http://schemas.microsoft.com/office/drawing/2014/main" id="{D617AB41-6AD1-9EF2-7F95-46A904399681}"/>
+              </a:ext>
+            </a:extLst>
+          </p:cNvPr>
+          <p:cNvSpPr>
+            <a:spLocks noGrp="1"/>
+          </p:cNvSpPr>
+          <p:nvPr>
+            <p:ph type="title"/>
+          </p:nvPr>
+        </p:nvSpPr>
+        <p:spPr/>
+        <p:txBody>
+          <a:bodyPr>
+            <a:noAutofit/>
+          </a:bodyPr>
+          <a:lstStyle/>
+          <a:p>
+            <a:r>
+              <a:rPr lang="en-US">
+                <a:solidFill>
+                  <a:srgbClr val="1F3864"/>
+                </a:solidFill>
+              </a:rPr>
+              <a:t>The Poisson distribution</a:t>
+            </a:r>
+          </a:p>
+        </p:txBody>
+      </p:sp>
+      <p:sp>
+        <p:nvSpPr>
+          <p:cNvPr id="4" name="Slide Number Placeholder 3">
+            <a:extLst>
+              <a:ext uri="{FF2B5EF4-FFF2-40B4-BE49-F238E27FC236}">
+                <a16:creationId xmlns:a16="http://schemas.microsoft.com/office/drawing/2014/main" id="{97D44AE5-98B5-B840-6B8A-D345C7C2E2F0}"/>
+              </a:ext>
+            </a:extLst>
+          </p:cNvPr>
+          <p:cNvSpPr>
+            <a:spLocks noGrp="1"/>
+          </p:cNvSpPr>
+          <p:nvPr>
+            <p:ph type="sldNum" sz="quarter" idx="12"/>
+          </p:nvPr>
+        </p:nvSpPr>
+        <p:spPr/>
+        <p:txBody>
+          <a:bodyPr/>
+          <a:lstStyle/>
+          <a:p>
+            <a:fld id="{A80A81DD-F10A-4B1C-963A-0ABBB4865886}" type="slidenum">
+              <a:rPr lang="en-US" sz="1600" smtClean="0"/>
+              <a:t>7</a:t>
             </a:fld>
             <a:endParaRPr lang="en-US" sz="1600"/>
           </a:p>
@@ -8761,7 +11018,7 @@
 </p:sld>
 </file>
 
-<file path=ppt/slides/slide7.xml><?xml version="1.0" encoding="utf-8"?>
+<file path=ppt/slides/slide8.xml><?xml version="1.0" encoding="utf-8"?>
 <p:sld xmlns:a="http://schemas.openxmlformats.org/drawingml/2006/main" xmlns:r="http://schemas.openxmlformats.org/officeDocument/2006/relationships" xmlns:p="http://schemas.openxmlformats.org/presentationml/2006/main">
   <p:cSld>
     <p:spTree>
@@ -8835,7 +11092,7 @@
           <a:p>
             <a:fld id="{A80A81DD-F10A-4B1C-963A-0ABBB4865886}" type="slidenum">
               <a:rPr lang="en-US" sz="1600" smtClean="0"/>
-              <a:t>7</a:t>
+              <a:t>8</a:t>
             </a:fld>
             <a:endParaRPr lang="en-US" sz="1600"/>
           </a:p>
@@ -9014,7 +11271,7 @@
         <p:spPr>
           <a:xfrm>
             <a:off x="762000" y="2711510"/>
-            <a:ext cx="10668000" cy="974626"/>
+            <a:ext cx="10668000" cy="671979"/>
           </a:xfrm>
           <a:prstGeom prst="rect">
             <a:avLst/>
@@ -9055,24 +11312,14 @@
                 </a:solidFill>
                 <a:latin typeface="Calibri" panose="020F0502020204030204" pitchFamily="34" charset="0"/>
               </a:rPr>
-              <a:t>(b)  How many of the 64 matches does the model expect to end 0–0?  (There were 7.)</a:t>
-            </a:r>
-          </a:p>
-          <a:p>
-            <a:pPr>
-              <a:spcAft>
-                <a:spcPts val="200"/>
-              </a:spcAft>
-            </a:pPr>
-            <a:r>
-              <a:rPr lang="en-US" b="1">
-                <a:solidFill>
-                  <a:srgbClr val="C00000"/>
-                </a:solidFill>
-                <a:latin typeface="Calibri" panose="020F0502020204030204" pitchFamily="34" charset="0"/>
-              </a:rPr>
-              <a:t>(c)  What is λ for one 45-minute half, and P(no goals in a half)?</a:t>
-            </a:r>
+              <a:t>(b)  What is P(X &gt; 1)?</a:t>
+            </a:r>
+            <a:endParaRPr lang="en-US" b="1" dirty="0">
+              <a:solidFill>
+                <a:srgbClr val="C00000"/>
+              </a:solidFill>
+              <a:latin typeface="Calibri" panose="020F0502020204030204" pitchFamily="34" charset="0"/>
+            </a:endParaRPr>
           </a:p>
         </p:txBody>
       </p:sp>
@@ -9090,8 +11337,8 @@
         </p:nvSpPr>
         <p:spPr>
           <a:xfrm>
-            <a:off x="762000" y="3838536"/>
-            <a:ext cx="10668000" cy="1098054"/>
+            <a:off x="762000" y="3539550"/>
+            <a:ext cx="10668000" cy="787400"/>
           </a:xfrm>
           <a:prstGeom prst="roundRect">
             <a:avLst>
@@ -9165,36 +11412,7 @@
                 </a:solidFill>
                 <a:latin typeface="Calibri" panose="020F0502020204030204" pitchFamily="34" charset="0"/>
               </a:rPr>
-              <a:t>(b)  64 × 0.068 ≈ 4.4:  close, but a model is never a perfect fit</a:t>
-            </a:r>
-          </a:p>
-          <a:p>
-            <a:r>
-              <a:rPr lang="en-US" sz="2000" b="1">
-                <a:solidFill>
-                  <a:srgbClr val="C00000"/>
-                </a:solidFill>
-                <a:latin typeface="Calibri" panose="020F0502020204030204" pitchFamily="34" charset="0"/>
-              </a:rPr>
-              <a:t>(c)  λ = 2.69 / 2 ≈ 1.34,     P(X = 0) = e</a:t>
-            </a:r>
-            <a:r>
-              <a:rPr lang="en-US" sz="2000" b="1" baseline="30000">
-                <a:solidFill>
-                  <a:srgbClr val="C00000"/>
-                </a:solidFill>
-                <a:latin typeface="Calibri" panose="020F0502020204030204" pitchFamily="34" charset="0"/>
-              </a:rPr>
-              <a:t>−1.34</a:t>
-            </a:r>
-            <a:r>
-              <a:rPr lang="en-US" sz="2000" b="1">
-                <a:solidFill>
-                  <a:srgbClr val="C00000"/>
-                </a:solidFill>
-                <a:latin typeface="Calibri" panose="020F0502020204030204" pitchFamily="34" charset="0"/>
-              </a:rPr>
-              <a:t> ≈ 0.26</a:t>
+              <a:t>(b)  1 − [P(0) + P(1)] = 1 − [0.068 + 2.69 × 0.068] ≈ 0.75</a:t>
             </a:r>
           </a:p>
         </p:txBody>
@@ -9203,436 +11421,6 @@
     <p:extLst>
       <p:ext uri="{BB962C8B-B14F-4D97-AF65-F5344CB8AC3E}">
         <p14:creationId xmlns:p14="http://schemas.microsoft.com/office/powerpoint/2010/main" val="1954285749"/>
-      </p:ext>
-    </p:extLst>
-  </p:cSld>
-  <p:clrMapOvr>
-    <a:masterClrMapping/>
-  </p:clrMapOvr>
-  <p:timing>
-    <p:tnLst>
-      <p:par>
-        <p:cTn id="1" dur="indefinite" restart="never" nodeType="tmRoot">
-          <p:childTnLst>
-            <p:seq concurrent="1" nextAc="seek">
-              <p:cTn id="2" dur="indefinite" nodeType="mainSeq">
-                <p:childTnLst>
-                  <p:par>
-                    <p:cTn id="3" fill="hold">
-                      <p:stCondLst>
-                        <p:cond delay="indefinite"/>
-                      </p:stCondLst>
-                      <p:childTnLst>
-                        <p:par>
-                          <p:cTn id="4" fill="hold">
-                            <p:stCondLst>
-                              <p:cond delay="0"/>
-                            </p:stCondLst>
-                            <p:childTnLst>
-                              <p:par>
-                                <p:cTn id="5" presetID="1" presetClass="entr" presetSubtype="0" fill="hold" grpId="0" nodeType="clickEffect">
-                                  <p:stCondLst>
-                                    <p:cond delay="0"/>
-                                  </p:stCondLst>
-                                  <p:childTnLst>
-                                    <p:set>
-                                      <p:cBhvr>
-                                        <p:cTn id="6" dur="1" fill="hold">
-                                          <p:stCondLst>
-                                            <p:cond delay="0"/>
-                                          </p:stCondLst>
-                                        </p:cTn>
-                                        <p:tgtEl>
-                                          <p:spTgt spid="11"/>
-                                        </p:tgtEl>
-                                        <p:attrNameLst>
-                                          <p:attrName>style.visibility</p:attrName>
-                                        </p:attrNameLst>
-                                      </p:cBhvr>
-                                      <p:to>
-                                        <p:strVal val="visible"/>
-                                      </p:to>
-                                    </p:set>
-                                  </p:childTnLst>
-                                </p:cTn>
-                              </p:par>
-                            </p:childTnLst>
-                          </p:cTn>
-                        </p:par>
-                      </p:childTnLst>
-                    </p:cTn>
-                  </p:par>
-                </p:childTnLst>
-              </p:cTn>
-              <p:prevCondLst>
-                <p:cond evt="onPrev" delay="0">
-                  <p:tgtEl>
-                    <p:sldTgt/>
-                  </p:tgtEl>
-                </p:cond>
-              </p:prevCondLst>
-              <p:nextCondLst>
-                <p:cond evt="onNext" delay="0">
-                  <p:tgtEl>
-                    <p:sldTgt/>
-                  </p:tgtEl>
-                </p:cond>
-              </p:nextCondLst>
-            </p:seq>
-          </p:childTnLst>
-        </p:cTn>
-      </p:par>
-    </p:tnLst>
-    <p:bldLst>
-      <p:bldP spid="11" grpId="0" animBg="1"/>
-    </p:bldLst>
-  </p:timing>
-</p:sld>
-</file>
-
-<file path=ppt/slides/slide8.xml><?xml version="1.0" encoding="utf-8"?>
-<p:sld xmlns:a="http://schemas.openxmlformats.org/drawingml/2006/main" xmlns:r="http://schemas.openxmlformats.org/officeDocument/2006/relationships" xmlns:p="http://schemas.openxmlformats.org/presentationml/2006/main">
-  <p:cSld>
-    <p:spTree>
-      <p:nvGrpSpPr>
-        <p:cNvPr id="1" name=""/>
-        <p:cNvGrpSpPr/>
-        <p:nvPr/>
-      </p:nvGrpSpPr>
-      <p:grpSpPr>
-        <a:xfrm>
-          <a:off x="0" y="0"/>
-          <a:ext cx="0" cy="0"/>
-          <a:chOff x="0" y="0"/>
-          <a:chExt cx="0" cy="0"/>
-        </a:xfrm>
-      </p:grpSpPr>
-      <p:sp>
-        <p:nvSpPr>
-          <p:cNvPr id="2" name="Title 1">
-            <a:extLst>
-              <a:ext uri="{FF2B5EF4-FFF2-40B4-BE49-F238E27FC236}">
-                <a16:creationId xmlns:a16="http://schemas.microsoft.com/office/drawing/2014/main" id="{C08D30B1-1864-30EF-7EAB-9BEE656C0012}"/>
-              </a:ext>
-            </a:extLst>
-          </p:cNvPr>
-          <p:cNvSpPr>
-            <a:spLocks noGrp="1"/>
-          </p:cNvSpPr>
-          <p:nvPr>
-            <p:ph type="title"/>
-          </p:nvPr>
-        </p:nvSpPr>
-        <p:spPr/>
-        <p:txBody>
-          <a:bodyPr>
-            <a:noAutofit/>
-          </a:bodyPr>
-          <a:lstStyle/>
-          <a:p>
-            <a:r>
-              <a:rPr lang="en-US">
-                <a:solidFill>
-                  <a:srgbClr val="1F3864"/>
-                </a:solidFill>
-              </a:rPr>
-              <a:t>Goals per match: the Poisson model</a:t>
-            </a:r>
-          </a:p>
-        </p:txBody>
-      </p:sp>
-      <p:sp>
-        <p:nvSpPr>
-          <p:cNvPr id="4" name="Slide Number Placeholder 3">
-            <a:extLst>
-              <a:ext uri="{FF2B5EF4-FFF2-40B4-BE49-F238E27FC236}">
-                <a16:creationId xmlns:a16="http://schemas.microsoft.com/office/drawing/2014/main" id="{3F875068-D051-44AE-498E-1BEBEDE3A7C8}"/>
-              </a:ext>
-            </a:extLst>
-          </p:cNvPr>
-          <p:cNvSpPr>
-            <a:spLocks noGrp="1"/>
-          </p:cNvSpPr>
-          <p:nvPr>
-            <p:ph type="sldNum" sz="quarter" idx="12"/>
-          </p:nvPr>
-        </p:nvSpPr>
-        <p:spPr/>
-        <p:txBody>
-          <a:bodyPr/>
-          <a:lstStyle/>
-          <a:p>
-            <a:fld id="{A80A81DD-F10A-4B1C-963A-0ABBB4865886}" type="slidenum">
-              <a:rPr lang="en-US" sz="1600" smtClean="0"/>
-              <a:t>8</a:t>
-            </a:fld>
-            <a:endParaRPr lang="en-US" sz="1600"/>
-          </a:p>
-        </p:txBody>
-      </p:sp>
-      <p:sp>
-        <p:nvSpPr>
-          <p:cNvPr id="3" name="Title rule">
-            <a:extLst>
-              <a:ext uri="{FF2B5EF4-FFF2-40B4-BE49-F238E27FC236}">
-                <a16:creationId xmlns:a16="http://schemas.microsoft.com/office/drawing/2014/main" id="{30656AA8-9645-F028-C769-A313710853CC}"/>
-              </a:ext>
-            </a:extLst>
-          </p:cNvPr>
-          <p:cNvSpPr/>
-          <p:nvPr/>
-        </p:nvSpPr>
-        <p:spPr>
-          <a:xfrm>
-            <a:off x="838200" y="1600200"/>
-            <a:ext cx="10515600" cy="38100"/>
-          </a:xfrm>
-          <a:prstGeom prst="rect">
-            <a:avLst/>
-          </a:prstGeom>
-          <a:solidFill>
-            <a:srgbClr val="4472C4"/>
-          </a:solidFill>
-          <a:ln w="12700" cap="flat" cmpd="sng" algn="ctr">
-            <a:noFill/>
-            <a:prstDash val="solid"/>
-            <a:miter lim="800000"/>
-          </a:ln>
-          <a:effectLst/>
-          <a:extLst>
-            <a:ext uri="{91240B29-F687-4F45-9708-019B960494DF}">
-              <a14:hiddenLine xmlns:a14="http://schemas.microsoft.com/office/drawing/2010/main" w="12700" cap="flat" cmpd="sng" algn="ctr">
-                <a:solidFill>
-                  <a:schemeClr val="accent1">
-                    <a:shade val="15000"/>
-                  </a:schemeClr>
-                </a:solidFill>
-                <a:prstDash val="solid"/>
-                <a:miter lim="800000"/>
-              </a14:hiddenLine>
-            </a:ext>
-          </a:extLst>
-        </p:spPr>
-        <p:style>
-          <a:lnRef idx="2">
-            <a:schemeClr val="accent1">
-              <a:shade val="15000"/>
-            </a:schemeClr>
-          </a:lnRef>
-          <a:fillRef idx="1">
-            <a:schemeClr val="accent1"/>
-          </a:fillRef>
-          <a:effectRef idx="0">
-            <a:schemeClr val="accent1"/>
-          </a:effectRef>
-          <a:fontRef idx="minor">
-            <a:schemeClr val="lt1"/>
-          </a:fontRef>
-        </p:style>
-        <p:txBody>
-          <a:bodyPr rtlCol="0" anchor="ctr"/>
-          <a:lstStyle/>
-          <a:p>
-            <a:pPr algn="ctr"/>
-            <a:endParaRPr lang="en-US"/>
-          </a:p>
-        </p:txBody>
-      </p:sp>
-      <p:sp>
-        <p:nvSpPr>
-          <p:cNvPr id="8" name="Context">
-            <a:extLst>
-              <a:ext uri="{FF2B5EF4-FFF2-40B4-BE49-F238E27FC236}">
-                <a16:creationId xmlns:a16="http://schemas.microsoft.com/office/drawing/2014/main" id="{71E3EA8C-31B4-DAD4-BC4A-65D72E59AD46}"/>
-              </a:ext>
-            </a:extLst>
-          </p:cNvPr>
-          <p:cNvSpPr txBox="1"/>
-          <p:nvPr/>
-        </p:nvSpPr>
-        <p:spPr>
-          <a:xfrm>
-            <a:off x="762000" y="1879600"/>
-            <a:ext cx="10668000" cy="381000"/>
-          </a:xfrm>
-          <a:prstGeom prst="rect">
-            <a:avLst/>
-          </a:prstGeom>
-          <a:noFill/>
-        </p:spPr>
-        <p:txBody>
-          <a:bodyPr vert="horz" wrap="square" rtlCol="0">
-            <a:spAutoFit/>
-          </a:bodyPr>
-          <a:lstStyle/>
-          <a:p>
-            <a:pPr>
-              <a:spcAft>
-                <a:spcPts val="200"/>
-              </a:spcAft>
-            </a:pPr>
-            <a:r>
-              <a:rPr lang="en-US">
-                <a:solidFill>
-                  <a:srgbClr val="000000"/>
-                </a:solidFill>
-                <a:latin typeface="Calibri" panose="020F0502020204030204" pitchFamily="34" charset="0"/>
-              </a:rPr>
-              <a:t>X ~ Poisson(λ = 2.69): the probability of each number of goals in a match.</a:t>
-            </a:r>
-          </a:p>
-        </p:txBody>
-      </p:sp>
-      <p:sp>
-        <p:nvSpPr>
-          <p:cNvPr id="10" name="Question">
-            <a:extLst>
-              <a:ext uri="{FF2B5EF4-FFF2-40B4-BE49-F238E27FC236}">
-                <a16:creationId xmlns:a16="http://schemas.microsoft.com/office/drawing/2014/main" id="{B31E395F-B84E-D1E9-D22A-222467FC4105}"/>
-              </a:ext>
-            </a:extLst>
-          </p:cNvPr>
-          <p:cNvSpPr txBox="1"/>
-          <p:nvPr/>
-        </p:nvSpPr>
-        <p:spPr>
-          <a:xfrm>
-            <a:off x="762000" y="2286000"/>
-            <a:ext cx="10668000" cy="369332"/>
-          </a:xfrm>
-          <a:prstGeom prst="rect">
-            <a:avLst/>
-          </a:prstGeom>
-          <a:noFill/>
-        </p:spPr>
-        <p:txBody>
-          <a:bodyPr vert="horz" wrap="square" rtlCol="0">
-            <a:spAutoFit/>
-          </a:bodyPr>
-          <a:lstStyle/>
-          <a:p>
-            <a:pPr>
-              <a:spcAft>
-                <a:spcPts val="200"/>
-              </a:spcAft>
-            </a:pPr>
-            <a:r>
-              <a:rPr lang="en-US" b="1">
-                <a:solidFill>
-                  <a:srgbClr val="C00000"/>
-                </a:solidFill>
-                <a:latin typeface="Calibri" panose="020F0502020204030204" pitchFamily="34" charset="0"/>
-              </a:rPr>
-              <a:t>Which number of goals is most likely? Is the distribution symmetric?</a:t>
-            </a:r>
-          </a:p>
-        </p:txBody>
-      </p:sp>
-      <p:sp>
-        <p:nvSpPr>
-          <p:cNvPr id="11" name="Result">
-            <a:extLst>
-              <a:ext uri="{FF2B5EF4-FFF2-40B4-BE49-F238E27FC236}">
-                <a16:creationId xmlns:a16="http://schemas.microsoft.com/office/drawing/2014/main" id="{5A70F68E-0D93-07B8-82B2-4D8F2F681D0D}"/>
-              </a:ext>
-            </a:extLst>
-          </p:cNvPr>
-          <p:cNvSpPr/>
-          <p:nvPr/>
-        </p:nvSpPr>
-        <p:spPr>
-          <a:xfrm>
-            <a:off x="762000" y="5639832"/>
-            <a:ext cx="10668000" cy="470595"/>
-          </a:xfrm>
-          <a:prstGeom prst="roundRect">
-            <a:avLst>
-              <a:gd name="adj" fmla="val 4000"/>
-            </a:avLst>
-          </a:prstGeom>
-          <a:solidFill>
-            <a:srgbClr val="F2F6FC"/>
-          </a:solidFill>
-          <a:ln w="15875">
-            <a:solidFill>
-              <a:srgbClr val="4472C4"/>
-            </a:solidFill>
-          </a:ln>
-        </p:spPr>
-        <p:style>
-          <a:lnRef idx="2">
-            <a:schemeClr val="accent1">
-              <a:shade val="15000"/>
-            </a:schemeClr>
-          </a:lnRef>
-          <a:fillRef idx="1">
-            <a:schemeClr val="accent1"/>
-          </a:fillRef>
-          <a:effectRef idx="0">
-            <a:schemeClr val="accent1"/>
-          </a:effectRef>
-          <a:fontRef idx="minor">
-            <a:schemeClr val="lt1"/>
-          </a:fontRef>
-        </p:style>
-        <p:txBody>
-          <a:bodyPr wrap="square" lIns="152400" tIns="76200" rIns="152400" bIns="76200" rtlCol="0" anchor="ctr">
-            <a:spAutoFit/>
-          </a:bodyPr>
-          <a:lstStyle/>
-          <a:p>
-            <a:r>
-              <a:rPr lang="en-US" sz="2000" b="1">
-                <a:solidFill>
-                  <a:srgbClr val="C00000"/>
-                </a:solidFill>
-                <a:latin typeface="Calibri" panose="020F0502020204030204" pitchFamily="34" charset="0"/>
-              </a:rPr>
-              <a:t>Two goals (0.25), then three (0.22);  skewed right:  X cannot go below 0 but has no upper limit</a:t>
-            </a:r>
-          </a:p>
-        </p:txBody>
-      </p:sp>
-      <p:pic>
-        <p:nvPicPr>
-          <p:cNvPr id="6" name="l15_poisson_goals.png">
-            <a:extLst>
-              <a:ext uri="{FF2B5EF4-FFF2-40B4-BE49-F238E27FC236}">
-                <a16:creationId xmlns:a16="http://schemas.microsoft.com/office/drawing/2014/main" id="{AC90B376-2A68-DB13-3770-4696990C57A0}"/>
-              </a:ext>
-            </a:extLst>
-          </p:cNvPr>
-          <p:cNvPicPr>
-            <a:picLocks/>
-          </p:cNvPicPr>
-          <p:nvPr/>
-        </p:nvPicPr>
-        <p:blipFill>
-          <a:blip r:embed="rId2">
-            <a:extLst>
-              <a:ext uri="{28A0092B-C50C-407E-A947-70E740481C1C}">
-                <a14:useLocalDpi xmlns:a14="http://schemas.microsoft.com/office/drawing/2010/main" val="0"/>
-              </a:ext>
-            </a:extLst>
-          </a:blip>
-          <a:stretch>
-            <a:fillRect/>
-          </a:stretch>
-        </p:blipFill>
-        <p:spPr>
-          <a:xfrm>
-            <a:off x="2032000" y="2706132"/>
-            <a:ext cx="8128000" cy="2857500"/>
-          </a:xfrm>
-          <a:prstGeom prst="rect">
-            <a:avLst/>
-          </a:prstGeom>
-        </p:spPr>
-      </p:pic>
-    </p:spTree>
-    <p:extLst>
-      <p:ext uri="{BB962C8B-B14F-4D97-AF65-F5344CB8AC3E}">
-        <p14:creationId xmlns:p14="http://schemas.microsoft.com/office/powerpoint/2010/main" val="4138504504"/>
       </p:ext>
     </p:extLst>
   </p:cSld>
@@ -9742,7 +11530,7 @@
           <p:cNvPr id="2" name="Title 1">
             <a:extLst>
               <a:ext uri="{FF2B5EF4-FFF2-40B4-BE49-F238E27FC236}">
-                <a16:creationId xmlns:a16="http://schemas.microsoft.com/office/drawing/2014/main" id="{D617AB41-6AD1-9EF2-7F95-46A904399681}"/>
+                <a16:creationId xmlns:a16="http://schemas.microsoft.com/office/drawing/2014/main" id="{C08D30B1-1864-30EF-7EAB-9BEE656C0012}"/>
               </a:ext>
             </a:extLst>
           </p:cNvPr>
@@ -9766,7 +11554,7 @@
                   <a:srgbClr val="1F3864"/>
                 </a:solidFill>
               </a:rPr>
-              <a:t>The normal as a continuous distribution</a:t>
+              <a:t>Goals per match: the Poisson model</a:t>
             </a:r>
           </a:p>
         </p:txBody>
@@ -9776,7 +11564,7 @@
           <p:cNvPr id="4" name="Slide Number Placeholder 3">
             <a:extLst>
               <a:ext uri="{FF2B5EF4-FFF2-40B4-BE49-F238E27FC236}">
-                <a16:creationId xmlns:a16="http://schemas.microsoft.com/office/drawing/2014/main" id="{97D44AE5-98B5-B840-6B8A-D345C7C2E2F0}"/>
+                <a16:creationId xmlns:a16="http://schemas.microsoft.com/office/drawing/2014/main" id="{3F875068-D051-44AE-498E-1BEBEDE3A7C8}"/>
               </a:ext>
             </a:extLst>
           </p:cNvPr>
@@ -9802,265 +11590,10 @@
       </p:sp>
       <p:sp>
         <p:nvSpPr>
-          <p:cNvPr id="5" name="TextBox 4">
-            <a:extLst>
-              <a:ext uri="{FF2B5EF4-FFF2-40B4-BE49-F238E27FC236}">
-                <a16:creationId xmlns:a16="http://schemas.microsoft.com/office/drawing/2014/main" id="{A34AAE17-27CE-D7A3-C663-11BB48ACBF5B}"/>
-              </a:ext>
-            </a:extLst>
-          </p:cNvPr>
-          <p:cNvSpPr txBox="1"/>
-          <p:nvPr/>
-        </p:nvSpPr>
-        <p:spPr>
-          <a:xfrm>
-            <a:off x="762000" y="1879600"/>
-            <a:ext cx="10668000" cy="345440"/>
-          </a:xfrm>
-          <a:prstGeom prst="rect">
-            <a:avLst/>
-          </a:prstGeom>
-          <a:noFill/>
-        </p:spPr>
-        <p:txBody>
-          <a:bodyPr vert="horz" wrap="square" rtlCol="0">
-            <a:spAutoFit/>
-          </a:bodyPr>
-          <a:lstStyle/>
-          <a:p>
-            <a:pPr marL="304800" indent="-304800"/>
-            <a:r>
-              <a:rPr lang="en-US" sz="1600">
-                <a:solidFill>
-                  <a:srgbClr val="000000"/>
-                </a:solidFill>
-              </a:rPr>
-              <a:t>X ~ N(</a:t>
-            </a:r>
-            <a:r>
-              <a:rPr lang="el-GR" sz="1600">
-                <a:solidFill>
-                  <a:srgbClr val="000000"/>
-                </a:solidFill>
-              </a:rPr>
-              <a:t>μ, σ)</a:t>
-            </a:r>
-            <a:endParaRPr lang="en-US" sz="1600">
-              <a:solidFill>
-                <a:srgbClr val="000000"/>
-              </a:solidFill>
-            </a:endParaRPr>
-          </a:p>
-        </p:txBody>
-      </p:sp>
-      <p:sp>
-        <p:nvSpPr>
-          <p:cNvPr id="6" name="TextBox 5">
-            <a:extLst>
-              <a:ext uri="{FF2B5EF4-FFF2-40B4-BE49-F238E27FC236}">
-                <a16:creationId xmlns:a16="http://schemas.microsoft.com/office/drawing/2014/main" id="{E410A0F8-5E1E-9A1D-B64C-50827EE6C9B2}"/>
-              </a:ext>
-            </a:extLst>
-          </p:cNvPr>
-          <p:cNvSpPr txBox="1"/>
-          <p:nvPr/>
-        </p:nvSpPr>
-        <p:spPr>
-          <a:xfrm>
-            <a:off x="1117600" y="2225040"/>
-            <a:ext cx="10312400" cy="338554"/>
-          </a:xfrm>
-          <a:prstGeom prst="rect">
-            <a:avLst/>
-          </a:prstGeom>
-          <a:noFill/>
-        </p:spPr>
-        <p:txBody>
-          <a:bodyPr vert="horz" wrap="square" rtlCol="0">
-            <a:spAutoFit/>
-          </a:bodyPr>
-          <a:lstStyle/>
-          <a:p>
-            <a:r>
-              <a:rPr lang="en-US" sz="1600" b="1">
-                <a:solidFill>
-                  <a:srgbClr val="C00000"/>
-                </a:solidFill>
-              </a:rPr>
-              <a:t>a continuous random variable: it can take any value, and its density curve is the bell curve</a:t>
-            </a:r>
-          </a:p>
-        </p:txBody>
-      </p:sp>
-      <p:sp>
-        <p:nvSpPr>
-          <p:cNvPr id="7" name="TextBox 6">
-            <a:extLst>
-              <a:ext uri="{FF2B5EF4-FFF2-40B4-BE49-F238E27FC236}">
-                <a16:creationId xmlns:a16="http://schemas.microsoft.com/office/drawing/2014/main" id="{47D3CD95-D52E-5227-B663-7C0A72677B6E}"/>
-              </a:ext>
-            </a:extLst>
-          </p:cNvPr>
-          <p:cNvSpPr txBox="1"/>
-          <p:nvPr/>
-        </p:nvSpPr>
-        <p:spPr>
-          <a:xfrm>
-            <a:off x="762000" y="2741394"/>
-            <a:ext cx="10668000" cy="345440"/>
-          </a:xfrm>
-          <a:prstGeom prst="rect">
-            <a:avLst/>
-          </a:prstGeom>
-          <a:noFill/>
-        </p:spPr>
-        <p:txBody>
-          <a:bodyPr vert="horz" wrap="square" rtlCol="0">
-            <a:spAutoFit/>
-          </a:bodyPr>
-          <a:lstStyle/>
-          <a:p>
-            <a:pPr marL="304800" indent="-304800"/>
-            <a:r>
-              <a:rPr lang="en-US" sz="1600">
-                <a:solidFill>
-                  <a:srgbClr val="000000"/>
-                </a:solidFill>
-              </a:rPr>
-              <a:t>probability is area</a:t>
-            </a:r>
-          </a:p>
-        </p:txBody>
-      </p:sp>
-      <p:sp>
-        <p:nvSpPr>
-          <p:cNvPr id="8" name="TextBox 7">
-            <a:extLst>
-              <a:ext uri="{FF2B5EF4-FFF2-40B4-BE49-F238E27FC236}">
-                <a16:creationId xmlns:a16="http://schemas.microsoft.com/office/drawing/2014/main" id="{1CE3E601-601D-C6B1-8265-C079CB8C9269}"/>
-              </a:ext>
-            </a:extLst>
-          </p:cNvPr>
-          <p:cNvSpPr txBox="1"/>
-          <p:nvPr/>
-        </p:nvSpPr>
-        <p:spPr>
-          <a:xfrm>
-            <a:off x="1117600" y="3086834"/>
-            <a:ext cx="10312400" cy="338554"/>
-          </a:xfrm>
-          <a:prstGeom prst="rect">
-            <a:avLst/>
-          </a:prstGeom>
-          <a:noFill/>
-        </p:spPr>
-        <p:txBody>
-          <a:bodyPr vert="horz" wrap="square" rtlCol="0">
-            <a:spAutoFit/>
-          </a:bodyPr>
-          <a:lstStyle/>
-          <a:p>
-            <a:r>
-              <a:rPr lang="en-US" sz="1600" b="1">
-                <a:solidFill>
-                  <a:srgbClr val="C00000"/>
-                </a:solidFill>
-              </a:rPr>
-              <a:t>P(a &lt; X &lt; b) is the area under the curve between a and b;  the height is not a probability</a:t>
-            </a:r>
-          </a:p>
-        </p:txBody>
-      </p:sp>
-      <p:sp>
-        <p:nvSpPr>
-          <p:cNvPr id="9" name="TextBox 8">
-            <a:extLst>
-              <a:ext uri="{FF2B5EF4-FFF2-40B4-BE49-F238E27FC236}">
-                <a16:creationId xmlns:a16="http://schemas.microsoft.com/office/drawing/2014/main" id="{FB002BF4-8037-2F73-E27A-7A453477E389}"/>
-              </a:ext>
-            </a:extLst>
-          </p:cNvPr>
-          <p:cNvSpPr txBox="1"/>
-          <p:nvPr/>
-        </p:nvSpPr>
-        <p:spPr>
-          <a:xfrm>
-            <a:off x="762000" y="3603188"/>
-            <a:ext cx="10668000" cy="345440"/>
-          </a:xfrm>
-          <a:prstGeom prst="rect">
-            <a:avLst/>
-          </a:prstGeom>
-          <a:noFill/>
-        </p:spPr>
-        <p:txBody>
-          <a:bodyPr vert="horz" wrap="square" rtlCol="0">
-            <a:spAutoFit/>
-          </a:bodyPr>
-          <a:lstStyle/>
-          <a:p>
-            <a:pPr marL="304800" indent="-304800"/>
-            <a:r>
-              <a:rPr lang="en-US" sz="1600">
-                <a:solidFill>
-                  <a:srgbClr val="000000"/>
-                </a:solidFill>
-              </a:rPr>
-              <a:t>P(X = c) = 0</a:t>
-            </a:r>
-          </a:p>
-        </p:txBody>
-      </p:sp>
-      <p:sp>
-        <p:nvSpPr>
-          <p:cNvPr id="10" name="TextBox 9">
-            <a:extLst>
-              <a:ext uri="{FF2B5EF4-FFF2-40B4-BE49-F238E27FC236}">
-                <a16:creationId xmlns:a16="http://schemas.microsoft.com/office/drawing/2014/main" id="{10F3B3E3-D27C-E008-C93E-ED70BD2A4754}"/>
-              </a:ext>
-            </a:extLst>
-          </p:cNvPr>
-          <p:cNvSpPr txBox="1"/>
-          <p:nvPr/>
-        </p:nvSpPr>
-        <p:spPr>
-          <a:xfrm>
-            <a:off x="1117600" y="3948628"/>
-            <a:ext cx="10312400" cy="338554"/>
-          </a:xfrm>
-          <a:prstGeom prst="rect">
-            <a:avLst/>
-          </a:prstGeom>
-          <a:noFill/>
-        </p:spPr>
-        <p:txBody>
-          <a:bodyPr vert="horz" wrap="square" rtlCol="0">
-            <a:spAutoFit/>
-          </a:bodyPr>
-          <a:lstStyle/>
-          <a:p>
-            <a:r>
-              <a:rPr lang="en-US" sz="1600" b="1">
-                <a:solidFill>
-                  <a:srgbClr val="C00000"/>
-                </a:solidFill>
-              </a:rPr>
-              <a:t>a single value has no width, so P(X &lt; c) = P(X ≤ c)</a:t>
-            </a:r>
-            <a:endParaRPr lang="en-US" sz="1600" b="1" dirty="0">
-              <a:solidFill>
-                <a:srgbClr val="C00000"/>
-              </a:solidFill>
-            </a:endParaRPr>
-          </a:p>
-        </p:txBody>
-      </p:sp>
-      <p:sp>
-        <p:nvSpPr>
           <p:cNvPr id="3" name="Title rule">
             <a:extLst>
               <a:ext uri="{FF2B5EF4-FFF2-40B4-BE49-F238E27FC236}">
-                <a16:creationId xmlns:a16="http://schemas.microsoft.com/office/drawing/2014/main" id="{B469CAAB-2B69-6863-7C28-0C5959E5734B}"/>
+                <a16:creationId xmlns:a16="http://schemas.microsoft.com/office/drawing/2014/main" id="{30656AA8-9645-F028-C769-A313710853CC}"/>
               </a:ext>
             </a:extLst>
           </p:cNvPr>
@@ -10123,10 +11656,201 @@
           </a:p>
         </p:txBody>
       </p:sp>
+      <p:sp>
+        <p:nvSpPr>
+          <p:cNvPr id="8" name="Context">
+            <a:extLst>
+              <a:ext uri="{FF2B5EF4-FFF2-40B4-BE49-F238E27FC236}">
+                <a16:creationId xmlns:a16="http://schemas.microsoft.com/office/drawing/2014/main" id="{71E3EA8C-31B4-DAD4-BC4A-65D72E59AD46}"/>
+              </a:ext>
+            </a:extLst>
+          </p:cNvPr>
+          <p:cNvSpPr txBox="1"/>
+          <p:nvPr/>
+        </p:nvSpPr>
+        <p:spPr>
+          <a:xfrm>
+            <a:off x="762000" y="1879600"/>
+            <a:ext cx="10668000" cy="381000"/>
+          </a:xfrm>
+          <a:prstGeom prst="rect">
+            <a:avLst/>
+          </a:prstGeom>
+          <a:noFill/>
+        </p:spPr>
+        <p:txBody>
+          <a:bodyPr vert="horz" wrap="square" rtlCol="0">
+            <a:spAutoFit/>
+          </a:bodyPr>
+          <a:lstStyle/>
+          <a:p>
+            <a:pPr>
+              <a:spcAft>
+                <a:spcPts val="200"/>
+              </a:spcAft>
+            </a:pPr>
+            <a:r>
+              <a:rPr lang="en-US">
+                <a:solidFill>
+                  <a:srgbClr val="000000"/>
+                </a:solidFill>
+                <a:latin typeface="Calibri" panose="020F0502020204030204" pitchFamily="34" charset="0"/>
+              </a:rPr>
+              <a:t>X ~ Poisson(λ = 2.69): the probability of each number of goals in a match.</a:t>
+            </a:r>
+          </a:p>
+        </p:txBody>
+      </p:sp>
+      <p:sp>
+        <p:nvSpPr>
+          <p:cNvPr id="10" name="Question">
+            <a:extLst>
+              <a:ext uri="{FF2B5EF4-FFF2-40B4-BE49-F238E27FC236}">
+                <a16:creationId xmlns:a16="http://schemas.microsoft.com/office/drawing/2014/main" id="{B31E395F-B84E-D1E9-D22A-222467FC4105}"/>
+              </a:ext>
+            </a:extLst>
+          </p:cNvPr>
+          <p:cNvSpPr txBox="1"/>
+          <p:nvPr/>
+        </p:nvSpPr>
+        <p:spPr>
+          <a:xfrm>
+            <a:off x="762000" y="2286000"/>
+            <a:ext cx="10668000" cy="369332"/>
+          </a:xfrm>
+          <a:prstGeom prst="rect">
+            <a:avLst/>
+          </a:prstGeom>
+          <a:noFill/>
+        </p:spPr>
+        <p:txBody>
+          <a:bodyPr vert="horz" wrap="square" rtlCol="0">
+            <a:spAutoFit/>
+          </a:bodyPr>
+          <a:lstStyle/>
+          <a:p>
+            <a:pPr>
+              <a:spcAft>
+                <a:spcPts val="200"/>
+              </a:spcAft>
+            </a:pPr>
+            <a:r>
+              <a:rPr lang="en-US" b="1">
+                <a:solidFill>
+                  <a:srgbClr val="C00000"/>
+                </a:solidFill>
+                <a:latin typeface="Calibri" panose="020F0502020204030204" pitchFamily="34" charset="0"/>
+              </a:rPr>
+              <a:t>Which number of goals is most likely? Is the distribution symmetric?</a:t>
+            </a:r>
+          </a:p>
+        </p:txBody>
+      </p:sp>
+      <p:sp>
+        <p:nvSpPr>
+          <p:cNvPr id="11" name="Result">
+            <a:extLst>
+              <a:ext uri="{FF2B5EF4-FFF2-40B4-BE49-F238E27FC236}">
+                <a16:creationId xmlns:a16="http://schemas.microsoft.com/office/drawing/2014/main" id="{5A70F68E-0D93-07B8-82B2-4D8F2F681D0D}"/>
+              </a:ext>
+            </a:extLst>
+          </p:cNvPr>
+          <p:cNvSpPr/>
+          <p:nvPr/>
+        </p:nvSpPr>
+        <p:spPr>
+          <a:xfrm>
+            <a:off x="762000" y="5639832"/>
+            <a:ext cx="10668000" cy="470595"/>
+          </a:xfrm>
+          <a:prstGeom prst="roundRect">
+            <a:avLst>
+              <a:gd name="adj" fmla="val 4000"/>
+            </a:avLst>
+          </a:prstGeom>
+          <a:solidFill>
+            <a:srgbClr val="F2F6FC"/>
+          </a:solidFill>
+          <a:ln w="15875">
+            <a:solidFill>
+              <a:srgbClr val="4472C4"/>
+            </a:solidFill>
+          </a:ln>
+        </p:spPr>
+        <p:style>
+          <a:lnRef idx="2">
+            <a:schemeClr val="accent1">
+              <a:shade val="15000"/>
+            </a:schemeClr>
+          </a:lnRef>
+          <a:fillRef idx="1">
+            <a:schemeClr val="accent1"/>
+          </a:fillRef>
+          <a:effectRef idx="0">
+            <a:schemeClr val="accent1"/>
+          </a:effectRef>
+          <a:fontRef idx="minor">
+            <a:schemeClr val="lt1"/>
+          </a:fontRef>
+        </p:style>
+        <p:txBody>
+          <a:bodyPr wrap="square" lIns="152400" tIns="76200" rIns="152400" bIns="76200" rtlCol="0" anchor="ctr">
+            <a:spAutoFit/>
+          </a:bodyPr>
+          <a:lstStyle/>
+          <a:p>
+            <a:r>
+              <a:rPr lang="en-US" sz="2000" b="1">
+                <a:solidFill>
+                  <a:srgbClr val="C00000"/>
+                </a:solidFill>
+                <a:latin typeface="Calibri" panose="020F0502020204030204" pitchFamily="34" charset="0"/>
+              </a:rPr>
+              <a:t>Two goals (0.25), then three (0.22);  skewed right:  X cannot go below 0 but has no upper limit</a:t>
+            </a:r>
+          </a:p>
+        </p:txBody>
+      </p:sp>
+      <p:pic>
+        <p:nvPicPr>
+          <p:cNvPr id="6" name="l15_poisson_goals.png">
+            <a:extLst>
+              <a:ext uri="{FF2B5EF4-FFF2-40B4-BE49-F238E27FC236}">
+                <a16:creationId xmlns:a16="http://schemas.microsoft.com/office/drawing/2014/main" id="{AC90B376-2A68-DB13-3770-4696990C57A0}"/>
+              </a:ext>
+            </a:extLst>
+          </p:cNvPr>
+          <p:cNvPicPr>
+            <a:picLocks/>
+          </p:cNvPicPr>
+          <p:nvPr/>
+        </p:nvPicPr>
+        <p:blipFill>
+          <a:blip r:embed="rId2">
+            <a:extLst>
+              <a:ext uri="{28A0092B-C50C-407E-A947-70E740481C1C}">
+                <a14:useLocalDpi xmlns:a14="http://schemas.microsoft.com/office/drawing/2010/main" val="0"/>
+              </a:ext>
+            </a:extLst>
+          </a:blip>
+          <a:stretch>
+            <a:fillRect/>
+          </a:stretch>
+        </p:blipFill>
+        <p:spPr>
+          <a:xfrm>
+            <a:off x="2032000" y="2706132"/>
+            <a:ext cx="8128000" cy="2857500"/>
+          </a:xfrm>
+          <a:prstGeom prst="rect">
+            <a:avLst/>
+          </a:prstGeom>
+        </p:spPr>
+      </p:pic>
     </p:spTree>
     <p:extLst>
       <p:ext uri="{BB962C8B-B14F-4D97-AF65-F5344CB8AC3E}">
-        <p14:creationId xmlns:p14="http://schemas.microsoft.com/office/powerpoint/2010/main" val="3867227488"/>
+        <p14:creationId xmlns:p14="http://schemas.microsoft.com/office/powerpoint/2010/main" val="4138504504"/>
       </p:ext>
     </p:extLst>
   </p:cSld>
@@ -10154,7 +11878,7 @@
                             </p:stCondLst>
                             <p:childTnLst>
                               <p:par>
-                                <p:cTn id="5" presetID="34" presetClass="entr" presetSubtype="0" fill="hold" grpId="0" nodeType="clickEffect">
+                                <p:cTn id="5" presetID="1" presetClass="entr" presetSubtype="0" fill="hold" grpId="0" nodeType="clickEffect">
                                   <p:stCondLst>
                                     <p:cond delay="0"/>
                                   </p:stCondLst>
@@ -10167,7 +11891,7 @@
                                           </p:stCondLst>
                                         </p:cTn>
                                         <p:tgtEl>
-                                          <p:spTgt spid="6"/>
+                                          <p:spTgt spid="11"/>
                                         </p:tgtEl>
                                         <p:attrNameLst>
                                           <p:attrName>style.visibility</p:attrName>
@@ -10177,273 +11901,6 @@
                                         <p:strVal val="visible"/>
                                       </p:to>
                                     </p:set>
-                                    <p:anim from="(-#ppt_w/2)" to="(#ppt_x)" calcmode="lin" valueType="num">
-                                      <p:cBhvr>
-                                        <p:cTn id="7" dur="600" fill="hold">
-                                          <p:stCondLst>
-                                            <p:cond delay="0"/>
-                                          </p:stCondLst>
-                                        </p:cTn>
-                                        <p:tgtEl>
-                                          <p:spTgt spid="6"/>
-                                        </p:tgtEl>
-                                        <p:attrNameLst>
-                                          <p:attrName>ppt_x</p:attrName>
-                                        </p:attrNameLst>
-                                      </p:cBhvr>
-                                    </p:anim>
-                                    <p:anim from="0" to="-1.0" calcmode="lin" valueType="num">
-                                      <p:cBhvr>
-                                        <p:cTn id="8" dur="200" decel="50000" autoRev="1" fill="hold">
-                                          <p:stCondLst>
-                                            <p:cond delay="600"/>
-                                          </p:stCondLst>
-                                        </p:cTn>
-                                        <p:tgtEl>
-                                          <p:spTgt spid="6"/>
-                                        </p:tgtEl>
-                                        <p:attrNameLst>
-                                          <p:attrName>xshear</p:attrName>
-                                        </p:attrNameLst>
-                                      </p:cBhvr>
-                                    </p:anim>
-                                    <p:animScale>
-                                      <p:cBhvr>
-                                        <p:cTn id="9" dur="200" decel="100000" autoRev="1" fill="hold">
-                                          <p:stCondLst>
-                                            <p:cond delay="600"/>
-                                          </p:stCondLst>
-                                        </p:cTn>
-                                        <p:tgtEl>
-                                          <p:spTgt spid="6"/>
-                                        </p:tgtEl>
-                                      </p:cBhvr>
-                                      <p:from x="100000" y="100000"/>
-                                      <p:to x="80000" y="100000"/>
-                                    </p:animScale>
-                                    <p:anim by="(#ppt_h/3+#ppt_w*0.1)" calcmode="lin" valueType="num">
-                                      <p:cBhvr additive="sum">
-                                        <p:cTn id="10" dur="200" decel="100000" autoRev="1" fill="hold">
-                                          <p:stCondLst>
-                                            <p:cond delay="600"/>
-                                          </p:stCondLst>
-                                        </p:cTn>
-                                        <p:tgtEl>
-                                          <p:spTgt spid="6"/>
-                                        </p:tgtEl>
-                                        <p:attrNameLst>
-                                          <p:attrName>ppt_x</p:attrName>
-                                        </p:attrNameLst>
-                                      </p:cBhvr>
-                                    </p:anim>
-                                  </p:childTnLst>
-                                </p:cTn>
-                              </p:par>
-                            </p:childTnLst>
-                          </p:cTn>
-                        </p:par>
-                      </p:childTnLst>
-                    </p:cTn>
-                  </p:par>
-                  <p:par>
-                    <p:cTn id="11" fill="hold">
-                      <p:stCondLst>
-                        <p:cond delay="indefinite"/>
-                      </p:stCondLst>
-                      <p:childTnLst>
-                        <p:par>
-                          <p:cTn id="12" fill="hold">
-                            <p:stCondLst>
-                              <p:cond delay="0"/>
-                            </p:stCondLst>
-                            <p:childTnLst>
-                              <p:par>
-                                <p:cTn id="13" presetID="34" presetClass="entr" presetSubtype="0" fill="hold" grpId="0" nodeType="clickEffect">
-                                  <p:stCondLst>
-                                    <p:cond delay="0"/>
-                                  </p:stCondLst>
-                                  <p:childTnLst>
-                                    <p:set>
-                                      <p:cBhvr>
-                                        <p:cTn id="14" dur="1" fill="hold">
-                                          <p:stCondLst>
-                                            <p:cond delay="0"/>
-                                          </p:stCondLst>
-                                        </p:cTn>
-                                        <p:tgtEl>
-                                          <p:spTgt spid="8"/>
-                                        </p:tgtEl>
-                                        <p:attrNameLst>
-                                          <p:attrName>style.visibility</p:attrName>
-                                        </p:attrNameLst>
-                                      </p:cBhvr>
-                                      <p:to>
-                                        <p:strVal val="visible"/>
-                                      </p:to>
-                                    </p:set>
-                                    <p:anim from="(-#ppt_w/2)" to="(#ppt_x)" calcmode="lin" valueType="num">
-                                      <p:cBhvr>
-                                        <p:cTn id="15" dur="600" fill="hold">
-                                          <p:stCondLst>
-                                            <p:cond delay="0"/>
-                                          </p:stCondLst>
-                                        </p:cTn>
-                                        <p:tgtEl>
-                                          <p:spTgt spid="8"/>
-                                        </p:tgtEl>
-                                        <p:attrNameLst>
-                                          <p:attrName>ppt_x</p:attrName>
-                                        </p:attrNameLst>
-                                      </p:cBhvr>
-                                    </p:anim>
-                                    <p:anim from="0" to="-1.0" calcmode="lin" valueType="num">
-                                      <p:cBhvr>
-                                        <p:cTn id="16" dur="200" decel="50000" autoRev="1" fill="hold">
-                                          <p:stCondLst>
-                                            <p:cond delay="600"/>
-                                          </p:stCondLst>
-                                        </p:cTn>
-                                        <p:tgtEl>
-                                          <p:spTgt spid="8"/>
-                                        </p:tgtEl>
-                                        <p:attrNameLst>
-                                          <p:attrName>xshear</p:attrName>
-                                        </p:attrNameLst>
-                                      </p:cBhvr>
-                                    </p:anim>
-                                    <p:animScale>
-                                      <p:cBhvr>
-                                        <p:cTn id="17" dur="200" decel="100000" autoRev="1" fill="hold">
-                                          <p:stCondLst>
-                                            <p:cond delay="600"/>
-                                          </p:stCondLst>
-                                        </p:cTn>
-                                        <p:tgtEl>
-                                          <p:spTgt spid="8"/>
-                                        </p:tgtEl>
-                                      </p:cBhvr>
-                                      <p:from x="100000" y="100000"/>
-                                      <p:to x="80000" y="100000"/>
-                                    </p:animScale>
-                                    <p:anim by="(#ppt_h/3+#ppt_w*0.1)" calcmode="lin" valueType="num">
-                                      <p:cBhvr additive="sum">
-                                        <p:cTn id="18" dur="200" decel="100000" autoRev="1" fill="hold">
-                                          <p:stCondLst>
-                                            <p:cond delay="600"/>
-                                          </p:stCondLst>
-                                        </p:cTn>
-                                        <p:tgtEl>
-                                          <p:spTgt spid="8"/>
-                                        </p:tgtEl>
-                                        <p:attrNameLst>
-                                          <p:attrName>ppt_x</p:attrName>
-                                        </p:attrNameLst>
-                                      </p:cBhvr>
-                                    </p:anim>
-                                  </p:childTnLst>
-                                </p:cTn>
-                              </p:par>
-                            </p:childTnLst>
-                          </p:cTn>
-                        </p:par>
-                      </p:childTnLst>
-                    </p:cTn>
-                  </p:par>
-                  <p:par>
-                    <p:cTn id="19" fill="hold">
-                      <p:stCondLst>
-                        <p:cond delay="indefinite"/>
-                      </p:stCondLst>
-                      <p:childTnLst>
-                        <p:par>
-                          <p:cTn id="20" fill="hold">
-                            <p:stCondLst>
-                              <p:cond delay="0"/>
-                            </p:stCondLst>
-                            <p:childTnLst>
-                              <p:par>
-                                <p:cTn id="21" presetID="34" presetClass="entr" presetSubtype="0" fill="hold" grpId="0" nodeType="clickEffect">
-                                  <p:stCondLst>
-                                    <p:cond delay="0"/>
-                                  </p:stCondLst>
-                                  <p:childTnLst>
-                                    <p:set>
-                                      <p:cBhvr>
-                                        <p:cTn id="22" dur="1" fill="hold">
-                                          <p:stCondLst>
-                                            <p:cond delay="0"/>
-                                          </p:stCondLst>
-                                        </p:cTn>
-                                        <p:tgtEl>
-                                          <p:spTgt spid="10"/>
-                                        </p:tgtEl>
-                                        <p:attrNameLst>
-                                          <p:attrName>style.visibility</p:attrName>
-                                        </p:attrNameLst>
-                                      </p:cBhvr>
-                                      <p:to>
-                                        <p:strVal val="visible"/>
-                                      </p:to>
-                                    </p:set>
-                                    <p:anim from="(-#ppt_w/2)" to="(#ppt_x)" calcmode="lin" valueType="num">
-                                      <p:cBhvr>
-                                        <p:cTn id="23" dur="600" fill="hold">
-                                          <p:stCondLst>
-                                            <p:cond delay="0"/>
-                                          </p:stCondLst>
-                                        </p:cTn>
-                                        <p:tgtEl>
-                                          <p:spTgt spid="10"/>
-                                        </p:tgtEl>
-                                        <p:attrNameLst>
-                                          <p:attrName>ppt_x</p:attrName>
-                                        </p:attrNameLst>
-                                      </p:cBhvr>
-                                    </p:anim>
-                                    <p:anim from="0" to="-1.0" calcmode="lin" valueType="num">
-                                      <p:cBhvr>
-                                        <p:cTn id="24" dur="200" decel="50000" autoRev="1" fill="hold">
-                                          <p:stCondLst>
-                                            <p:cond delay="600"/>
-                                          </p:stCondLst>
-                                        </p:cTn>
-                                        <p:tgtEl>
-                                          <p:spTgt spid="10"/>
-                                        </p:tgtEl>
-                                        <p:attrNameLst>
-                                          <p:attrName>xshear</p:attrName>
-                                        </p:attrNameLst>
-                                      </p:cBhvr>
-                                    </p:anim>
-                                    <p:animScale>
-                                      <p:cBhvr>
-                                        <p:cTn id="25" dur="200" decel="100000" autoRev="1" fill="hold">
-                                          <p:stCondLst>
-                                            <p:cond delay="600"/>
-                                          </p:stCondLst>
-                                        </p:cTn>
-                                        <p:tgtEl>
-                                          <p:spTgt spid="10"/>
-                                        </p:tgtEl>
-                                      </p:cBhvr>
-                                      <p:from x="100000" y="100000"/>
-                                      <p:to x="80000" y="100000"/>
-                                    </p:animScale>
-                                    <p:anim by="(#ppt_h/3+#ppt_w*0.1)" calcmode="lin" valueType="num">
-                                      <p:cBhvr additive="sum">
-                                        <p:cTn id="26" dur="200" decel="100000" autoRev="1" fill="hold">
-                                          <p:stCondLst>
-                                            <p:cond delay="600"/>
-                                          </p:stCondLst>
-                                        </p:cTn>
-                                        <p:tgtEl>
-                                          <p:spTgt spid="10"/>
-                                        </p:tgtEl>
-                                        <p:attrNameLst>
-                                          <p:attrName>ppt_x</p:attrName>
-                                        </p:attrNameLst>
-                                      </p:cBhvr>
-                                    </p:anim>
                                   </p:childTnLst>
                                 </p:cTn>
                               </p:par>
@@ -10475,9 +11932,7 @@
       </p:par>
     </p:tnLst>
     <p:bldLst>
-      <p:bldP spid="6" grpId="0"/>
-      <p:bldP spid="8" grpId="0"/>
-      <p:bldP spid="10" grpId="0"/>
+      <p:bldP spid="11" grpId="0" animBg="1"/>
     </p:bldLst>
   </p:timing>
 </p:sld>

</xml_diff>